<commit_message>
explanation of presentation added
</commit_message>
<xml_diff>
--- a/research methods/term project - review article/slides/Explainable Identification of Human vs. LLM Generated Text_ A Systematic Review.pptx
+++ b/research methods/term project - review article/slides/Explainable Identification of Human vs. LLM Generated Text_ A Systematic Review.pptx
@@ -4,6 +4,9 @@
   <p:sldMasterIdLst>
     <p:sldMasterId id="2147483648" r:id="rId1"/>
   </p:sldMasterIdLst>
+  <p:notesMasterIdLst>
+    <p:notesMasterId r:id="rId20"/>
+  </p:notesMasterIdLst>
   <p:sldIdLst>
     <p:sldId id="256" r:id="rId2"/>
     <p:sldId id="257" r:id="rId3"/>
@@ -24,17 +27,116 @@
     <p:sldId id="272" r:id="rId18"/>
     <p:sldId id="273" r:id="rId19"/>
   </p:sldIdLst>
-  <p:notesMasterIdLst>
-    <p:notesMasterId r:id="rId20"/>
-  </p:notesMasterIdLst>
   <p:sldSz cx="16256000" cy="9144000"/>
   <p:notesSz cx="9144000" cy="16256000"/>
   <p:embeddedFontLst>
     <p:embeddedFont>
-      <p:font typeface="Quattrocento Sans" charset="-122" pitchFamily="34"/>
-      <p:regular r:id="rId25"/>
+      <p:font typeface="Quattrocento Sans" panose="020B0502050000020003" pitchFamily="34" charset="0"/>
+      <p:regular r:id="rId21"/>
+      <p:bold r:id="rId22"/>
+      <p:italic r:id="rId23"/>
     </p:embeddedFont>
   </p:embeddedFontLst>
+  <p:defaultTextStyle>
+    <a:defPPr>
+      <a:defRPr lang="en-US"/>
+    </a:defPPr>
+    <a:lvl1pPr marL="0" algn="l" defTabSz="914400" rtl="0" eaLnBrk="1" latinLnBrk="0" hangingPunct="1">
+      <a:defRPr sz="1800" kern="1200">
+        <a:solidFill>
+          <a:schemeClr val="tx1"/>
+        </a:solidFill>
+        <a:latin typeface="+mn-lt"/>
+        <a:ea typeface="+mn-ea"/>
+        <a:cs typeface="+mn-cs"/>
+      </a:defRPr>
+    </a:lvl1pPr>
+    <a:lvl2pPr marL="457200" algn="l" defTabSz="914400" rtl="0" eaLnBrk="1" latinLnBrk="0" hangingPunct="1">
+      <a:defRPr sz="1800" kern="1200">
+        <a:solidFill>
+          <a:schemeClr val="tx1"/>
+        </a:solidFill>
+        <a:latin typeface="+mn-lt"/>
+        <a:ea typeface="+mn-ea"/>
+        <a:cs typeface="+mn-cs"/>
+      </a:defRPr>
+    </a:lvl2pPr>
+    <a:lvl3pPr marL="914400" algn="l" defTabSz="914400" rtl="0" eaLnBrk="1" latinLnBrk="0" hangingPunct="1">
+      <a:defRPr sz="1800" kern="1200">
+        <a:solidFill>
+          <a:schemeClr val="tx1"/>
+        </a:solidFill>
+        <a:latin typeface="+mn-lt"/>
+        <a:ea typeface="+mn-ea"/>
+        <a:cs typeface="+mn-cs"/>
+      </a:defRPr>
+    </a:lvl3pPr>
+    <a:lvl4pPr marL="1371600" algn="l" defTabSz="914400" rtl="0" eaLnBrk="1" latinLnBrk="0" hangingPunct="1">
+      <a:defRPr sz="1800" kern="1200">
+        <a:solidFill>
+          <a:schemeClr val="tx1"/>
+        </a:solidFill>
+        <a:latin typeface="+mn-lt"/>
+        <a:ea typeface="+mn-ea"/>
+        <a:cs typeface="+mn-cs"/>
+      </a:defRPr>
+    </a:lvl4pPr>
+    <a:lvl5pPr marL="1828800" algn="l" defTabSz="914400" rtl="0" eaLnBrk="1" latinLnBrk="0" hangingPunct="1">
+      <a:defRPr sz="1800" kern="1200">
+        <a:solidFill>
+          <a:schemeClr val="tx1"/>
+        </a:solidFill>
+        <a:latin typeface="+mn-lt"/>
+        <a:ea typeface="+mn-ea"/>
+        <a:cs typeface="+mn-cs"/>
+      </a:defRPr>
+    </a:lvl5pPr>
+    <a:lvl6pPr marL="2286000" algn="l" defTabSz="914400" rtl="0" eaLnBrk="1" latinLnBrk="0" hangingPunct="1">
+      <a:defRPr sz="1800" kern="1200">
+        <a:solidFill>
+          <a:schemeClr val="tx1"/>
+        </a:solidFill>
+        <a:latin typeface="+mn-lt"/>
+        <a:ea typeface="+mn-ea"/>
+        <a:cs typeface="+mn-cs"/>
+      </a:defRPr>
+    </a:lvl6pPr>
+    <a:lvl7pPr marL="2743200" algn="l" defTabSz="914400" rtl="0" eaLnBrk="1" latinLnBrk="0" hangingPunct="1">
+      <a:defRPr sz="1800" kern="1200">
+        <a:solidFill>
+          <a:schemeClr val="tx1"/>
+        </a:solidFill>
+        <a:latin typeface="+mn-lt"/>
+        <a:ea typeface="+mn-ea"/>
+        <a:cs typeface="+mn-cs"/>
+      </a:defRPr>
+    </a:lvl7pPr>
+    <a:lvl8pPr marL="3200400" algn="l" defTabSz="914400" rtl="0" eaLnBrk="1" latinLnBrk="0" hangingPunct="1">
+      <a:defRPr sz="1800" kern="1200">
+        <a:solidFill>
+          <a:schemeClr val="tx1"/>
+        </a:solidFill>
+        <a:latin typeface="+mn-lt"/>
+        <a:ea typeface="+mn-ea"/>
+        <a:cs typeface="+mn-cs"/>
+      </a:defRPr>
+    </a:lvl8pPr>
+    <a:lvl9pPr marL="3657600" algn="l" defTabSz="914400" rtl="0" eaLnBrk="1" latinLnBrk="0" hangingPunct="1">
+      <a:defRPr sz="1800" kern="1200">
+        <a:solidFill>
+          <a:schemeClr val="tx1"/>
+        </a:solidFill>
+        <a:latin typeface="+mn-lt"/>
+        <a:ea typeface="+mn-ea"/>
+        <a:cs typeface="+mn-cs"/>
+      </a:defRPr>
+    </a:lvl9pPr>
+  </p:defaultTextStyle>
+  <p:extLst>
+    <p:ext uri="{EFAFB233-063F-42B5-8137-9DF3F51BA10A}">
+      <p15:sldGuideLst xmlns:p15="http://schemas.microsoft.com/office/powerpoint/2012/main"/>
+    </p:ext>
+  </p:extLst>
 </p:presentation>
 </file>
 
@@ -60,234 +162,10 @@
           <a:chExt cx="0" cy="0"/>
         </a:xfrm>
       </p:grpSpPr>
-      <p:sp>
-        <p:nvSpPr>
-          <p:cNvPr id="2" name="Header Placeholder 1"/>
-          <p:cNvSpPr>
-            <a:spLocks noGrp="1"/>
-          </p:cNvSpPr>
-          <p:nvPr>
-            <p:ph type="hdr" sz="quarter"/>
-          </p:nvPr>
-        </p:nvSpPr>
-        <p:spPr>
-          <a:xfrm>
-            <a:off x="0" y="0"/>
-            <a:ext cx="2971800" cy="458788"/>
-          </a:xfrm>
-          <a:prstGeom prst="rect">
-            <a:avLst/>
-          </a:prstGeom>
-        </p:spPr>
-        <p:txBody>
-          <a:bodyPr vert="horz" lIns="91440" tIns="45720" rIns="91440" bIns="45720" rtlCol="0"/>
-          <a:lstStyle>
-            <a:lvl1pPr algn="l">
-              <a:defRPr sz="1200"/>
-            </a:lvl1pPr>
-          </a:lstStyle>
-          <a:p>
-            <a:endParaRPr lang="en-US"/>
-          </a:p>
-        </p:txBody>
-      </p:sp>
-      <p:sp>
-        <p:nvSpPr>
-          <p:cNvPr id="3" name="Date Placeholder 2"/>
-          <p:cNvSpPr>
-            <a:spLocks noGrp="1"/>
-          </p:cNvSpPr>
-          <p:nvPr>
-            <p:ph type="dt" idx="1"/>
-          </p:nvPr>
-        </p:nvSpPr>
-        <p:spPr>
-          <a:xfrm>
-            <a:off x="3884613" y="0"/>
-            <a:ext cx="2971800" cy="458788"/>
-          </a:xfrm>
-          <a:prstGeom prst="rect">
-            <a:avLst/>
-          </a:prstGeom>
-        </p:spPr>
-        <p:txBody>
-          <a:bodyPr vert="horz" lIns="91440" tIns="45720" rIns="91440" bIns="45720" rtlCol="0"/>
-          <a:lstStyle>
-            <a:lvl1pPr algn="r">
-              <a:defRPr sz="1200"/>
-            </a:lvl1pPr>
-          </a:lstStyle>
-          <a:p>
-            <a:fld id="{5282F153-3F37-0F45-9E97-73ACFA13230C}" type="datetimeFigureOut">
-              <a:rPr lang="en-US"/>
-              <a:t>7/23/19</a:t>
-            </a:fld>
-            <a:endParaRPr lang="en-US"/>
-          </a:p>
-        </p:txBody>
-      </p:sp>
-      <p:sp>
-        <p:nvSpPr>
-          <p:cNvPr id="4" name="Slide Image Placeholder 3"/>
-          <p:cNvSpPr>
-            <a:spLocks noGrp="1" noRot="1" noChangeAspect="1"/>
-          </p:cNvSpPr>
-          <p:nvPr>
-            <p:ph type="sldImg" idx="2"/>
-          </p:nvPr>
-        </p:nvSpPr>
-        <p:spPr>
-          <a:xfrm>
-            <a:off x="685800" y="1143000"/>
-            <a:ext cx="5486400" cy="3086100"/>
-          </a:xfrm>
-          <a:prstGeom prst="rect">
-            <a:avLst/>
-          </a:prstGeom>
-          <a:noFill/>
-          <a:ln w="12700">
-            <a:solidFill>
-              <a:prstClr val="black"/>
-            </a:solidFill>
-          </a:ln>
-        </p:spPr>
-        <p:txBody>
-          <a:bodyPr vert="horz" lIns="91440" tIns="45720" rIns="91440" bIns="45720" rtlCol="0" anchor="ctr"/>
-          <a:lstStyle/>
-          <a:p>
-            <a:endParaRPr lang="en-US"/>
-          </a:p>
-        </p:txBody>
-      </p:sp>
-      <p:sp>
-        <p:nvSpPr>
-          <p:cNvPr id="5" name="Notes Placeholder 4"/>
-          <p:cNvSpPr>
-            <a:spLocks noGrp="1"/>
-          </p:cNvSpPr>
-          <p:nvPr>
-            <p:ph type="body" sz="quarter" idx="3"/>
-          </p:nvPr>
-        </p:nvSpPr>
-        <p:spPr>
-          <a:xfrm>
-            <a:off x="685800" y="4400550"/>
-            <a:ext cx="5486400" cy="3600450"/>
-          </a:xfrm>
-          <a:prstGeom prst="rect">
-            <a:avLst/>
-          </a:prstGeom>
-        </p:spPr>
-        <p:txBody>
-          <a:bodyPr vert="horz" lIns="91440" tIns="45720" rIns="91440" bIns="45720" rtlCol="0"/>
-          <a:lstStyle/>
-          <a:p>
-            <a:pPr lvl="0"/>
-            <a:r>
-              <a:rPr lang="en-US"/>
-              <a:t>Click to edit Master text styles</a:t>
-            </a:r>
-          </a:p>
-          <a:p>
-            <a:pPr lvl="1"/>
-            <a:r>
-              <a:rPr lang="en-US"/>
-              <a:t>Second level</a:t>
-            </a:r>
-          </a:p>
-          <a:p>
-            <a:pPr lvl="2"/>
-            <a:r>
-              <a:rPr lang="en-US"/>
-              <a:t>Third level</a:t>
-            </a:r>
-          </a:p>
-          <a:p>
-            <a:pPr lvl="3"/>
-            <a:r>
-              <a:rPr lang="en-US"/>
-              <a:t>Fourth level</a:t>
-            </a:r>
-          </a:p>
-          <a:p>
-            <a:pPr lvl="4"/>
-            <a:r>
-              <a:rPr lang="en-US"/>
-              <a:t>Fifth level</a:t>
-            </a:r>
-          </a:p>
-        </p:txBody>
-      </p:sp>
-      <p:sp>
-        <p:nvSpPr>
-          <p:cNvPr id="6" name="Footer Placeholder 5"/>
-          <p:cNvSpPr>
-            <a:spLocks noGrp="1"/>
-          </p:cNvSpPr>
-          <p:nvPr>
-            <p:ph type="ftr" sz="quarter" idx="4"/>
-          </p:nvPr>
-        </p:nvSpPr>
-        <p:spPr>
-          <a:xfrm>
-            <a:off x="0" y="8685213"/>
-            <a:ext cx="2971800" cy="458787"/>
-          </a:xfrm>
-          <a:prstGeom prst="rect">
-            <a:avLst/>
-          </a:prstGeom>
-        </p:spPr>
-        <p:txBody>
-          <a:bodyPr vert="horz" lIns="91440" tIns="45720" rIns="91440" bIns="45720" rtlCol="0" anchor="b"/>
-          <a:lstStyle>
-            <a:lvl1pPr algn="l">
-              <a:defRPr sz="1200"/>
-            </a:lvl1pPr>
-          </a:lstStyle>
-          <a:p>
-            <a:endParaRPr lang="en-US"/>
-          </a:p>
-        </p:txBody>
-      </p:sp>
-      <p:sp>
-        <p:nvSpPr>
-          <p:cNvPr id="7" name="Slide Number Placeholder 6"/>
-          <p:cNvSpPr>
-            <a:spLocks noGrp="1"/>
-          </p:cNvSpPr>
-          <p:nvPr>
-            <p:ph type="sldNum" sz="quarter" idx="5"/>
-          </p:nvPr>
-        </p:nvSpPr>
-        <p:spPr>
-          <a:xfrm>
-            <a:off x="3884613" y="8685213"/>
-            <a:ext cx="2971800" cy="458787"/>
-          </a:xfrm>
-          <a:prstGeom prst="rect">
-            <a:avLst/>
-          </a:prstGeom>
-        </p:spPr>
-        <p:txBody>
-          <a:bodyPr vert="horz" lIns="91440" tIns="45720" rIns="91440" bIns="45720" rtlCol="0" anchor="b"/>
-          <a:lstStyle>
-            <a:lvl1pPr algn="r">
-              <a:defRPr sz="1200"/>
-            </a:lvl1pPr>
-          </a:lstStyle>
-          <a:p>
-            <a:fld id="{CE5E9CC1-C706-0F49-92D6-E571CC5EEA8F}" type="slidenum">
-              <a:rPr lang="en-US"/>
-              <a:t>‹#›</a:t>
-            </a:fld>
-            <a:endParaRPr lang="en-US"/>
-          </a:p>
-        </p:txBody>
-      </p:sp>
     </p:spTree>
     <p:extLst>
       <p:ext uri="{BB962C8B-B14F-4D97-AF65-F5344CB8AC3E}">
-        <p14:creationId xmlns:p14="http://schemas.microsoft.com/office/powerpoint/2010/main" val="1024086991"/>
+        <p14:creationId xmlns:p14="http://schemas.microsoft.com/office/powerpoint/2010/main" val="955281178"/>
       </p:ext>
     </p:extLst>
   </p:cSld>
@@ -431,10 +309,6 @@
           <a:bodyPr/>
           <a:lstStyle/>
           <a:p>
-            <a:r>
-              <a:rPr lang="en-US" dirty="0"/>
-              <a:t/>
-            </a:r>
             <a:endParaRPr lang="en-US" dirty="0"/>
           </a:p>
         </p:txBody>
@@ -519,10 +393,6 @@
           <a:bodyPr/>
           <a:lstStyle/>
           <a:p>
-            <a:r>
-              <a:rPr lang="en-US" dirty="0"/>
-              <a:t/>
-            </a:r>
             <a:endParaRPr lang="en-US" dirty="0"/>
           </a:p>
         </p:txBody>
@@ -607,10 +477,6 @@
           <a:bodyPr/>
           <a:lstStyle/>
           <a:p>
-            <a:r>
-              <a:rPr lang="en-US" dirty="0"/>
-              <a:t/>
-            </a:r>
             <a:endParaRPr lang="en-US" dirty="0"/>
           </a:p>
         </p:txBody>
@@ -695,10 +561,6 @@
           <a:bodyPr/>
           <a:lstStyle/>
           <a:p>
-            <a:r>
-              <a:rPr lang="en-US" dirty="0"/>
-              <a:t/>
-            </a:r>
             <a:endParaRPr lang="en-US" dirty="0"/>
           </a:p>
         </p:txBody>
@@ -783,10 +645,6 @@
           <a:bodyPr/>
           <a:lstStyle/>
           <a:p>
-            <a:r>
-              <a:rPr lang="en-US" dirty="0"/>
-              <a:t/>
-            </a:r>
             <a:endParaRPr lang="en-US" dirty="0"/>
           </a:p>
         </p:txBody>
@@ -871,10 +729,6 @@
           <a:bodyPr/>
           <a:lstStyle/>
           <a:p>
-            <a:r>
-              <a:rPr lang="en-US" dirty="0"/>
-              <a:t/>
-            </a:r>
             <a:endParaRPr lang="en-US" dirty="0"/>
           </a:p>
         </p:txBody>
@@ -959,10 +813,6 @@
           <a:bodyPr/>
           <a:lstStyle/>
           <a:p>
-            <a:r>
-              <a:rPr lang="en-US" dirty="0"/>
-              <a:t/>
-            </a:r>
             <a:endParaRPr lang="en-US" dirty="0"/>
           </a:p>
         </p:txBody>
@@ -1047,10 +897,6 @@
           <a:bodyPr/>
           <a:lstStyle/>
           <a:p>
-            <a:r>
-              <a:rPr lang="en-US" dirty="0"/>
-              <a:t/>
-            </a:r>
             <a:endParaRPr lang="en-US" dirty="0"/>
           </a:p>
         </p:txBody>
@@ -1135,10 +981,6 @@
           <a:bodyPr/>
           <a:lstStyle/>
           <a:p>
-            <a:r>
-              <a:rPr lang="en-US" dirty="0"/>
-              <a:t/>
-            </a:r>
             <a:endParaRPr lang="en-US" dirty="0"/>
           </a:p>
         </p:txBody>
@@ -1223,10 +1065,6 @@
           <a:bodyPr/>
           <a:lstStyle/>
           <a:p>
-            <a:r>
-              <a:rPr lang="en-US" dirty="0"/>
-              <a:t/>
-            </a:r>
             <a:endParaRPr lang="en-US" dirty="0"/>
           </a:p>
         </p:txBody>
@@ -1311,10 +1149,6 @@
           <a:bodyPr/>
           <a:lstStyle/>
           <a:p>
-            <a:r>
-              <a:rPr lang="en-US" dirty="0"/>
-              <a:t/>
-            </a:r>
             <a:endParaRPr lang="en-US" dirty="0"/>
           </a:p>
         </p:txBody>
@@ -1399,10 +1233,6 @@
           <a:bodyPr/>
           <a:lstStyle/>
           <a:p>
-            <a:r>
-              <a:rPr lang="en-US" dirty="0"/>
-              <a:t/>
-            </a:r>
             <a:endParaRPr lang="en-US" dirty="0"/>
           </a:p>
         </p:txBody>
@@ -1487,10 +1317,6 @@
           <a:bodyPr/>
           <a:lstStyle/>
           <a:p>
-            <a:r>
-              <a:rPr lang="en-US" dirty="0"/>
-              <a:t/>
-            </a:r>
             <a:endParaRPr lang="en-US" dirty="0"/>
           </a:p>
         </p:txBody>
@@ -1575,10 +1401,6 @@
           <a:bodyPr/>
           <a:lstStyle/>
           <a:p>
-            <a:r>
-              <a:rPr lang="en-US" dirty="0"/>
-              <a:t/>
-            </a:r>
             <a:endParaRPr lang="en-US" dirty="0"/>
           </a:p>
         </p:txBody>
@@ -1663,10 +1485,6 @@
           <a:bodyPr/>
           <a:lstStyle/>
           <a:p>
-            <a:r>
-              <a:rPr lang="en-US" dirty="0"/>
-              <a:t/>
-            </a:r>
             <a:endParaRPr lang="en-US" dirty="0"/>
           </a:p>
         </p:txBody>
@@ -1751,10 +1569,6 @@
           <a:bodyPr/>
           <a:lstStyle/>
           <a:p>
-            <a:r>
-              <a:rPr lang="en-US" dirty="0"/>
-              <a:t/>
-            </a:r>
             <a:endParaRPr lang="en-US" dirty="0"/>
           </a:p>
         </p:txBody>
@@ -1839,10 +1653,6 @@
           <a:bodyPr/>
           <a:lstStyle/>
           <a:p>
-            <a:r>
-              <a:rPr lang="en-US" dirty="0"/>
-              <a:t/>
-            </a:r>
             <a:endParaRPr lang="en-US" dirty="0"/>
           </a:p>
         </p:txBody>
@@ -1927,10 +1737,6 @@
           <a:bodyPr/>
           <a:lstStyle/>
           <a:p>
-            <a:r>
-              <a:rPr lang="en-US" dirty="0"/>
-              <a:t/>
-            </a:r>
             <a:endParaRPr lang="en-US" dirty="0"/>
           </a:p>
         </p:txBody>
@@ -1998,6 +1804,18 @@
   <p:clrMapOvr>
     <a:masterClrMapping/>
   </p:clrMapOvr>
+  <mc:AlternateContent xmlns:mc="http://schemas.openxmlformats.org/markup-compatibility/2006">
+    <mc:Choice xmlns:p159="http://schemas.microsoft.com/office/powerpoint/2015/09/main" Requires="p159">
+      <p:transition spd="slow">
+        <p159:morph option="byObject"/>
+      </p:transition>
+    </mc:Choice>
+    <mc:Fallback>
+      <p:transition spd="slow">
+        <p:fade/>
+      </p:transition>
+    </mc:Fallback>
+  </mc:AlternateContent>
 </p:sldLayout>
 </file>
 
@@ -2009,6 +1827,7 @@
         <a:solidFill>
           <a:srgbClr val="FFFFFF"/>
         </a:solidFill>
+        <a:effectLst/>
       </p:bgPr>
     </p:bg>
     <p:spTree>
@@ -2030,12 +1849,29 @@
   <p:clrMapOvr>
     <a:masterClrMapping/>
   </p:clrMapOvr>
+  <mc:AlternateContent xmlns:mc="http://schemas.openxmlformats.org/markup-compatibility/2006">
+    <mc:Choice xmlns:p159="http://schemas.microsoft.com/office/powerpoint/2015/09/main" Requires="p159">
+      <p:transition spd="slow">
+        <p159:morph option="byObject"/>
+      </p:transition>
+    </mc:Choice>
+    <mc:Fallback>
+      <p:transition spd="slow">
+        <p:fade/>
+      </p:transition>
+    </mc:Fallback>
+  </mc:AlternateContent>
 </p:sldLayout>
 </file>
 
 <file path=ppt/slideMasters/slideMaster1.xml><?xml version="1.0" encoding="utf-8"?>
 <p:sldMaster xmlns:a="http://schemas.openxmlformats.org/drawingml/2006/main" xmlns:r="http://schemas.openxmlformats.org/officeDocument/2006/relationships" xmlns:p="http://schemas.openxmlformats.org/presentationml/2006/main">
   <p:cSld>
+    <p:bg>
+      <p:bgRef idx="1001">
+        <a:schemeClr val="bg1"/>
+      </p:bgRef>
+    </p:bg>
     <p:spTree>
       <p:nvGrpSpPr>
         <p:cNvPr id="1" name=""/>
@@ -2057,6 +1893,18 @@
     <p:sldLayoutId id="2147483649" r:id="rId1"/>
     <p:sldLayoutId id="2147483650" r:id="rId2"/>
   </p:sldLayoutIdLst>
+  <mc:AlternateContent xmlns:mc="http://schemas.openxmlformats.org/markup-compatibility/2006">
+    <mc:Choice xmlns:p159="http://schemas.microsoft.com/office/powerpoint/2015/09/main" Requires="p159">
+      <p:transition spd="slow">
+        <p159:morph option="byObject"/>
+      </p:transition>
+    </mc:Choice>
+    <mc:Fallback>
+      <p:transition spd="slow">
+        <p:fade/>
+      </p:transition>
+    </mc:Fallback>
+  </mc:AlternateContent>
   <p:hf sldNum="0" hdr="0" ftr="0" dt="0"/>
   <p:txStyles>
     <p:titleStyle>
@@ -2319,6 +2167,7 @@
         <a:solidFill>
           <a:srgbClr val="F5F5F0"/>
         </a:solidFill>
+        <a:effectLst/>
       </p:bgPr>
     </p:bg>
     <p:spTree>
@@ -2601,10 +2450,18 @@
   <p:clrMapOvr>
     <a:masterClrMapping/>
   </p:clrMapOvr>
-  <p:transition>
-    <p:fade/>
-    <p:spd val="med"/>
-  </p:transition>
+  <mc:AlternateContent xmlns:mc="http://schemas.openxmlformats.org/markup-compatibility/2006">
+    <mc:Choice xmlns:p159="http://schemas.microsoft.com/office/powerpoint/2015/09/main" Requires="p159">
+      <p:transition spd="slow">
+        <p159:morph option="byObject"/>
+      </p:transition>
+    </mc:Choice>
+    <mc:Fallback>
+      <p:transition spd="slow">
+        <p:fade/>
+      </p:transition>
+    </mc:Fallback>
+  </mc:AlternateContent>
 </p:sld>
 </file>
 
@@ -2616,6 +2473,7 @@
         <a:solidFill>
           <a:srgbClr val="F5F5F0"/>
         </a:solidFill>
+        <a:effectLst/>
       </p:bgPr>
     </p:bg>
     <p:spTree>
@@ -2689,11 +2547,6 @@
               </a:rPr>
               <a:t>Introduction | Methodology | </a:t>
             </a:r>
-            <a:pPr algn="ctr">
-              <a:lnSpc>
-                <a:spcPct val="100000"/>
-              </a:lnSpc>
-            </a:pPr>
             <a:r>
               <a:rPr lang="en-US" sz="1200" b="1" dirty="0">
                 <a:solidFill>
@@ -2705,11 +2558,6 @@
               </a:rPr>
               <a:t>Thematic Analysis</a:t>
             </a:r>
-            <a:pPr algn="ctr">
-              <a:lnSpc>
-                <a:spcPct val="100000"/>
-              </a:lnSpc>
-            </a:pPr>
             <a:r>
               <a:rPr lang="en-US" sz="1200" dirty="0">
                 <a:solidFill>
@@ -2823,11 +2671,6 @@
               </a:rPr>
               <a:t>Four studies using </a:t>
             </a:r>
-            <a:pPr>
-              <a:lnSpc>
-                <a:spcPct val="150000"/>
-              </a:lnSpc>
-            </a:pPr>
             <a:r>
               <a:rPr lang="en-US" sz="2000" b="1" dirty="0">
                 <a:solidFill>
@@ -2839,11 +2682,6 @@
               </a:rPr>
               <a:t>fine-tuned transformer architectures</a:t>
             </a:r>
-            <a:pPr>
-              <a:lnSpc>
-                <a:spcPct val="150000"/>
-              </a:lnSpc>
-            </a:pPr>
             <a:r>
               <a:rPr lang="en-US" sz="2000" dirty="0">
                 <a:solidFill>
@@ -3303,14 +3141,6 @@
               </a:rPr>
               <a:t>Evaluative superlatives</a:t>
             </a:r>
-            <a:pPr>
-              <a:lnSpc>
-                <a:spcPct val="150000"/>
-              </a:lnSpc>
-              <a:spcBef>
-                <a:spcPts val="10"/>
-              </a:spcBef>
-            </a:pPr>
             <a:r>
               <a:rPr lang="en-US" sz="1800" dirty="0">
                 <a:solidFill>
@@ -3346,14 +3176,6 @@
               </a:rPr>
               <a:t>Formulaic hedging language</a:t>
             </a:r>
-            <a:pPr>
-              <a:lnSpc>
-                <a:spcPct val="150000"/>
-              </a:lnSpc>
-              <a:spcBef>
-                <a:spcPts val="10"/>
-              </a:spcBef>
-            </a:pPr>
             <a:r>
               <a:rPr lang="en-US" sz="1800" dirty="0">
                 <a:solidFill>
@@ -3389,14 +3211,6 @@
               </a:rPr>
               <a:t>LIME and SHAP agree</a:t>
             </a:r>
-            <a:pPr>
-              <a:lnSpc>
-                <a:spcPct val="150000"/>
-              </a:lnSpc>
-              <a:spcBef>
-                <a:spcPts val="10"/>
-              </a:spcBef>
-            </a:pPr>
             <a:r>
               <a:rPr lang="en-US" sz="1800" dirty="0">
                 <a:solidFill>
@@ -3432,14 +3246,6 @@
               </a:rPr>
               <a:t>The Adversarial Paradox</a:t>
             </a:r>
-            <a:pPr>
-              <a:lnSpc>
-                <a:spcPct val="150000"/>
-              </a:lnSpc>
-              <a:spcBef>
-                <a:spcPts val="10"/>
-              </a:spcBef>
-            </a:pPr>
             <a:r>
               <a:rPr lang="en-US" sz="1800" dirty="0">
                 <a:solidFill>
@@ -3492,11 +3298,6 @@
               </a:rPr>
               <a:t>Accuracy:</a:t>
             </a:r>
-            <a:pPr>
-              <a:lnSpc>
-                <a:spcPct val="100000"/>
-              </a:lnSpc>
-            </a:pPr>
             <a:r>
               <a:rPr lang="en-US" sz="1800" dirty="0">
                 <a:solidFill>
@@ -3508,11 +3309,6 @@
               </a:rPr>
               <a:t> ~91% (RoBERTa-Sentinel) | </a:t>
             </a:r>
-            <a:pPr>
-              <a:lnSpc>
-                <a:spcPct val="100000"/>
-              </a:lnSpc>
-            </a:pPr>
             <a:r>
               <a:rPr lang="en-US" sz="1800" b="1" dirty="0">
                 <a:solidFill>
@@ -3524,11 +3320,6 @@
               </a:rPr>
               <a:t>Key insight:</a:t>
             </a:r>
-            <a:pPr>
-              <a:lnSpc>
-                <a:spcPct val="100000"/>
-              </a:lnSpc>
-            </a:pPr>
             <a:r>
               <a:rPr lang="en-US" sz="1800" dirty="0">
                 <a:solidFill>
@@ -3590,10 +3381,18 @@
   <p:clrMapOvr>
     <a:masterClrMapping/>
   </p:clrMapOvr>
-  <p:transition>
-    <p:fade/>
-    <p:spd val="med"/>
-  </p:transition>
+  <mc:AlternateContent xmlns:mc="http://schemas.openxmlformats.org/markup-compatibility/2006">
+    <mc:Choice xmlns:p159="http://schemas.microsoft.com/office/powerpoint/2015/09/main" Requires="p159">
+      <p:transition spd="slow">
+        <p159:morph option="byObject"/>
+      </p:transition>
+    </mc:Choice>
+    <mc:Fallback>
+      <p:transition spd="slow">
+        <p:fade/>
+      </p:transition>
+    </mc:Fallback>
+  </mc:AlternateContent>
 </p:sld>
 </file>
 
@@ -3605,6 +3404,7 @@
         <a:solidFill>
           <a:srgbClr val="F5F5F0"/>
         </a:solidFill>
+        <a:effectLst/>
       </p:bgPr>
     </p:bg>
     <p:spTree>
@@ -3678,11 +3478,6 @@
               </a:rPr>
               <a:t>Introduction | Methodology | </a:t>
             </a:r>
-            <a:pPr algn="ctr">
-              <a:lnSpc>
-                <a:spcPct val="100000"/>
-              </a:lnSpc>
-            </a:pPr>
             <a:r>
               <a:rPr lang="en-US" sz="1200" b="1" dirty="0">
                 <a:solidFill>
@@ -3694,11 +3489,6 @@
               </a:rPr>
               <a:t>Thematic Analysis</a:t>
             </a:r>
-            <a:pPr algn="ctr">
-              <a:lnSpc>
-                <a:spcPct val="100000"/>
-              </a:lnSpc>
-            </a:pPr>
             <a:r>
               <a:rPr lang="en-US" sz="1200" dirty="0">
                 <a:solidFill>
@@ -3812,11 +3602,6 @@
               </a:rPr>
               <a:t>Five studies moving </a:t>
             </a:r>
-            <a:pPr>
-              <a:lnSpc>
-                <a:spcPct val="150000"/>
-              </a:lnSpc>
-            </a:pPr>
             <a:r>
               <a:rPr lang="en-US" sz="1800" b="1" dirty="0">
                 <a:solidFill>
@@ -3828,11 +3613,6 @@
               </a:rPr>
               <a:t>beyond binary classification</a:t>
             </a:r>
-            <a:pPr>
-              <a:lnSpc>
-                <a:spcPct val="150000"/>
-              </a:lnSpc>
-            </a:pPr>
             <a:r>
               <a:rPr lang="en-US" sz="1800" dirty="0">
                 <a:solidFill>
@@ -3912,9 +3692,27 @@
             <a:tbl>
               <a:tblPr/>
               <a:tblGrid>
-                <a:gridCol w="2651760"/>
-                <a:gridCol w="6187440"/>
-                <a:gridCol w="5892800"/>
+                <a:gridCol w="2651760">
+                  <a:extLst>
+                    <a:ext uri="{9D8B030D-6E8A-4147-A177-3AD203B41FA5}">
+                      <a16:colId xmlns:a16="http://schemas.microsoft.com/office/drawing/2014/main" val="20000"/>
+                    </a:ext>
+                  </a:extLst>
+                </a:gridCol>
+                <a:gridCol w="6187440">
+                  <a:extLst>
+                    <a:ext uri="{9D8B030D-6E8A-4147-A177-3AD203B41FA5}">
+                      <a16:colId xmlns:a16="http://schemas.microsoft.com/office/drawing/2014/main" val="20001"/>
+                    </a:ext>
+                  </a:extLst>
+                </a:gridCol>
+                <a:gridCol w="5892800">
+                  <a:extLst>
+                    <a:ext uri="{9D8B030D-6E8A-4147-A177-3AD203B41FA5}">
+                      <a16:colId xmlns:a16="http://schemas.microsoft.com/office/drawing/2014/main" val="20002"/>
+                    </a:ext>
+                  </a:extLst>
+                </a:gridCol>
               </a:tblGrid>
               <a:tr h="584200">
                 <a:tc>
@@ -3941,7 +3739,7 @@
                       </a:endParaRPr>
                     </a:p>
                   </a:txBody>
-                  <a:tcPr marL="91440" marR="91440" marT="0" marB="0" anchor="ctr">
+                  <a:tcPr marT="0" marB="0" anchor="ctr">
                     <a:lnL w="12700" cap="flat" cmpd="sng" algn="ctr">
                       <a:solidFill>
                         <a:srgbClr val="D0D5D2"/>
@@ -4007,7 +3805,7 @@
                       </a:endParaRPr>
                     </a:p>
                   </a:txBody>
-                  <a:tcPr marL="91440" marR="91440" marT="0" marB="0" anchor="ctr">
+                  <a:tcPr marT="0" marB="0" anchor="ctr">
                     <a:lnL w="12700" cap="flat" cmpd="sng" algn="ctr">
                       <a:solidFill>
                         <a:srgbClr val="D0D5D2"/>
@@ -4073,7 +3871,7 @@
                       </a:endParaRPr>
                     </a:p>
                   </a:txBody>
-                  <a:tcPr marL="91440" marR="91440" marT="0" marB="0" anchor="ctr">
+                  <a:tcPr marT="0" marB="0" anchor="ctr">
                     <a:lnL w="12700" cap="flat" cmpd="sng" algn="ctr">
                       <a:solidFill>
                         <a:srgbClr val="D0D5D2"/>
@@ -4115,6 +3913,11 @@
                     </a:solidFill>
                   </a:tcPr>
                 </a:tc>
+                <a:extLst>
+                  <a:ext uri="{0D108BD9-81ED-4DB2-BD59-A6C34878D82A}">
+                    <a16:rowId xmlns:a16="http://schemas.microsoft.com/office/drawing/2014/main" val="10000"/>
+                  </a:ext>
+                </a:extLst>
               </a:tr>
               <a:tr h="584200">
                 <a:tc>
@@ -4141,7 +3944,7 @@
                       </a:endParaRPr>
                     </a:p>
                   </a:txBody>
-                  <a:tcPr marL="91440" marR="91440" marT="0" marB="0" anchor="ctr">
+                  <a:tcPr marT="0" marB="0" anchor="ctr">
                     <a:lnL w="12700" cap="flat" cmpd="sng" algn="ctr">
                       <a:solidFill>
                         <a:srgbClr val="D0D5D2"/>
@@ -4207,7 +4010,7 @@
                       </a:endParaRPr>
                     </a:p>
                   </a:txBody>
-                  <a:tcPr marL="91440" marR="91440" marT="0" marB="0" anchor="ctr">
+                  <a:tcPr marT="0" marB="0" anchor="ctr">
                     <a:lnL w="12700" cap="flat" cmpd="sng" algn="ctr">
                       <a:solidFill>
                         <a:srgbClr val="D0D5D2"/>
@@ -4273,7 +4076,7 @@
                       </a:endParaRPr>
                     </a:p>
                   </a:txBody>
-                  <a:tcPr marL="91440" marR="91440" marT="0" marB="0" anchor="ctr">
+                  <a:tcPr marT="0" marB="0" anchor="ctr">
                     <a:lnL w="12700" cap="flat" cmpd="sng" algn="ctr">
                       <a:solidFill>
                         <a:srgbClr val="D0D5D2"/>
@@ -4315,6 +4118,11 @@
                     </a:solidFill>
                   </a:tcPr>
                 </a:tc>
+                <a:extLst>
+                  <a:ext uri="{0D108BD9-81ED-4DB2-BD59-A6C34878D82A}">
+                    <a16:rowId xmlns:a16="http://schemas.microsoft.com/office/drawing/2014/main" val="10001"/>
+                  </a:ext>
+                </a:extLst>
               </a:tr>
               <a:tr h="584200">
                 <a:tc>
@@ -4341,7 +4149,7 @@
                       </a:endParaRPr>
                     </a:p>
                   </a:txBody>
-                  <a:tcPr marL="91440" marR="91440" marT="0" marB="0" anchor="ctr">
+                  <a:tcPr marT="0" marB="0" anchor="ctr">
                     <a:lnL w="12700" cap="flat" cmpd="sng" algn="ctr">
                       <a:solidFill>
                         <a:srgbClr val="D0D5D2"/>
@@ -4407,7 +4215,7 @@
                       </a:endParaRPr>
                     </a:p>
                   </a:txBody>
-                  <a:tcPr marL="91440" marR="91440" marT="0" marB="0" anchor="ctr">
+                  <a:tcPr marT="0" marB="0" anchor="ctr">
                     <a:lnL w="12700" cap="flat" cmpd="sng" algn="ctr">
                       <a:solidFill>
                         <a:srgbClr val="D0D5D2"/>
@@ -4473,7 +4281,7 @@
                       </a:endParaRPr>
                     </a:p>
                   </a:txBody>
-                  <a:tcPr marL="91440" marR="91440" marT="0" marB="0" anchor="ctr">
+                  <a:tcPr marT="0" marB="0" anchor="ctr">
                     <a:lnL w="12700" cap="flat" cmpd="sng" algn="ctr">
                       <a:solidFill>
                         <a:srgbClr val="D0D5D2"/>
@@ -4515,6 +4323,11 @@
                     </a:solidFill>
                   </a:tcPr>
                 </a:tc>
+                <a:extLst>
+                  <a:ext uri="{0D108BD9-81ED-4DB2-BD59-A6C34878D82A}">
+                    <a16:rowId xmlns:a16="http://schemas.microsoft.com/office/drawing/2014/main" val="10002"/>
+                  </a:ext>
+                </a:extLst>
               </a:tr>
               <a:tr h="584200">
                 <a:tc>
@@ -4541,7 +4354,7 @@
                       </a:endParaRPr>
                     </a:p>
                   </a:txBody>
-                  <a:tcPr marL="91440" marR="91440" marT="0" marB="0" anchor="ctr">
+                  <a:tcPr marT="0" marB="0" anchor="ctr">
                     <a:lnL w="12700" cap="flat" cmpd="sng" algn="ctr">
                       <a:solidFill>
                         <a:srgbClr val="D0D5D2"/>
@@ -4607,7 +4420,7 @@
                       </a:endParaRPr>
                     </a:p>
                   </a:txBody>
-                  <a:tcPr marL="91440" marR="91440" marT="0" marB="0" anchor="ctr">
+                  <a:tcPr marT="0" marB="0" anchor="ctr">
                     <a:lnL w="12700" cap="flat" cmpd="sng" algn="ctr">
                       <a:solidFill>
                         <a:srgbClr val="D0D5D2"/>
@@ -4673,7 +4486,7 @@
                       </a:endParaRPr>
                     </a:p>
                   </a:txBody>
-                  <a:tcPr marL="91440" marR="91440" marT="0" marB="0" anchor="ctr">
+                  <a:tcPr marT="0" marB="0" anchor="ctr">
                     <a:lnL w="12700" cap="flat" cmpd="sng" algn="ctr">
                       <a:solidFill>
                         <a:srgbClr val="D0D5D2"/>
@@ -4715,6 +4528,11 @@
                     </a:solidFill>
                   </a:tcPr>
                 </a:tc>
+                <a:extLst>
+                  <a:ext uri="{0D108BD9-81ED-4DB2-BD59-A6C34878D82A}">
+                    <a16:rowId xmlns:a16="http://schemas.microsoft.com/office/drawing/2014/main" val="10003"/>
+                  </a:ext>
+                </a:extLst>
               </a:tr>
               <a:tr h="584200">
                 <a:tc>
@@ -4741,7 +4559,7 @@
                       </a:endParaRPr>
                     </a:p>
                   </a:txBody>
-                  <a:tcPr marL="91440" marR="91440" marT="0" marB="0" anchor="ctr">
+                  <a:tcPr marT="0" marB="0" anchor="ctr">
                     <a:lnL w="12700" cap="flat" cmpd="sng" algn="ctr">
                       <a:solidFill>
                         <a:srgbClr val="D0D5D2"/>
@@ -4807,7 +4625,7 @@
                       </a:endParaRPr>
                     </a:p>
                   </a:txBody>
-                  <a:tcPr marL="91440" marR="91440" marT="0" marB="0" anchor="ctr">
+                  <a:tcPr marT="0" marB="0" anchor="ctr">
                     <a:lnL w="12700" cap="flat" cmpd="sng" algn="ctr">
                       <a:solidFill>
                         <a:srgbClr val="D0D5D2"/>
@@ -4873,7 +4691,7 @@
                       </a:endParaRPr>
                     </a:p>
                   </a:txBody>
-                  <a:tcPr marL="91440" marR="91440" marT="0" marB="0" anchor="ctr">
+                  <a:tcPr marT="0" marB="0" anchor="ctr">
                     <a:lnL w="12700" cap="flat" cmpd="sng" algn="ctr">
                       <a:solidFill>
                         <a:srgbClr val="D0D5D2"/>
@@ -4915,6 +4733,11 @@
                     </a:solidFill>
                   </a:tcPr>
                 </a:tc>
+                <a:extLst>
+                  <a:ext uri="{0D108BD9-81ED-4DB2-BD59-A6C34878D82A}">
+                    <a16:rowId xmlns:a16="http://schemas.microsoft.com/office/drawing/2014/main" val="10004"/>
+                  </a:ext>
+                </a:extLst>
               </a:tr>
             </a:tbl>
           </a:graphicData>
@@ -4997,11 +4820,6 @@
               </a:rPr>
               <a:t>Key Finding:</a:t>
             </a:r>
-            <a:pPr>
-              <a:lnSpc>
-                <a:spcPct val="140000"/>
-              </a:lnSpc>
-            </a:pPr>
             <a:r>
               <a:rPr lang="en-US" sz="1800" dirty="0">
                 <a:solidFill>
@@ -5013,11 +4831,6 @@
               </a:rPr>
               <a:t> XAI enables </a:t>
             </a:r>
-            <a:pPr>
-              <a:lnSpc>
-                <a:spcPct val="140000"/>
-              </a:lnSpc>
-            </a:pPr>
             <a:r>
               <a:rPr lang="en-US" sz="1800" b="1" dirty="0">
                 <a:solidFill>
@@ -5029,11 +4842,6 @@
               </a:rPr>
               <a:t>source identification</a:t>
             </a:r>
-            <a:pPr>
-              <a:lnSpc>
-                <a:spcPct val="140000"/>
-              </a:lnSpc>
-            </a:pPr>
             <a:r>
               <a:rPr lang="en-US" sz="1800" dirty="0">
                 <a:solidFill>
@@ -5051,7 +4859,7 @@
       </p:sp>
       <p:sp>
         <p:nvSpPr>
-          <p:cNvPr id="12" name="Text 9"/>
+          <p:cNvPr id="8" name="Text 9"/>
           <p:cNvSpPr/>
           <p:nvPr/>
         </p:nvSpPr>
@@ -5086,11 +4894,6 @@
               </a:rPr>
               <a:t>Domain-specific:</a:t>
             </a:r>
-            <a:pPr>
-              <a:lnSpc>
-                <a:spcPct val="100000"/>
-              </a:lnSpc>
-            </a:pPr>
             <a:r>
               <a:rPr lang="en-US" sz="1800" dirty="0">
                 <a:solidFill>
@@ -5152,10 +4955,18 @@
   <p:clrMapOvr>
     <a:masterClrMapping/>
   </p:clrMapOvr>
-  <p:transition>
-    <p:fade/>
-    <p:spd val="med"/>
-  </p:transition>
+  <mc:AlternateContent xmlns:mc="http://schemas.openxmlformats.org/markup-compatibility/2006">
+    <mc:Choice xmlns:p159="http://schemas.microsoft.com/office/powerpoint/2015/09/main" Requires="p159">
+      <p:transition spd="slow">
+        <p159:morph option="byObject"/>
+      </p:transition>
+    </mc:Choice>
+    <mc:Fallback>
+      <p:transition spd="slow">
+        <p:fade/>
+      </p:transition>
+    </mc:Fallback>
+  </mc:AlternateContent>
 </p:sld>
 </file>
 
@@ -5167,6 +4978,7 @@
         <a:solidFill>
           <a:srgbClr val="1B5E3B"/>
         </a:solidFill>
+        <a:effectLst/>
       </p:bgPr>
     </p:bg>
     <p:spTree>
@@ -5335,10 +5147,18 @@
   <p:clrMapOvr>
     <a:masterClrMapping/>
   </p:clrMapOvr>
-  <p:transition>
-    <p:fade/>
-    <p:spd val="med"/>
-  </p:transition>
+  <mc:AlternateContent xmlns:mc="http://schemas.openxmlformats.org/markup-compatibility/2006">
+    <mc:Choice xmlns:p159="http://schemas.microsoft.com/office/powerpoint/2015/09/main" Requires="p159">
+      <p:transition spd="slow">
+        <p159:morph option="byObject"/>
+      </p:transition>
+    </mc:Choice>
+    <mc:Fallback>
+      <p:transition spd="slow">
+        <p:fade/>
+      </p:transition>
+    </mc:Fallback>
+  </mc:AlternateContent>
 </p:sld>
 </file>
 
@@ -5350,6 +5170,7 @@
         <a:solidFill>
           <a:srgbClr val="F5F5F0"/>
         </a:solidFill>
+        <a:effectLst/>
       </p:bgPr>
     </p:bg>
     <p:spTree>
@@ -5423,11 +5244,6 @@
               </a:rPr>
               <a:t>Introduction | Methodology | Thematic Analysis | </a:t>
             </a:r>
-            <a:pPr algn="ctr">
-              <a:lnSpc>
-                <a:spcPct val="100000"/>
-              </a:lnSpc>
-            </a:pPr>
             <a:r>
               <a:rPr lang="en-US" sz="1200" b="1" dirty="0">
                 <a:solidFill>
@@ -5439,11 +5255,6 @@
               </a:rPr>
               <a:t>Key Findings</a:t>
             </a:r>
-            <a:pPr algn="ctr">
-              <a:lnSpc>
-                <a:spcPct val="100000"/>
-              </a:lnSpc>
-            </a:pPr>
             <a:r>
               <a:rPr lang="en-US" sz="1200" dirty="0">
                 <a:solidFill>
@@ -5618,11 +5429,6 @@
               </a:rPr>
               <a:t>Convergent Validity</a:t>
             </a:r>
-            <a:pPr>
-              <a:lnSpc>
-                <a:spcPct val="140000"/>
-              </a:lnSpc>
-            </a:pPr>
             <a:r>
               <a:rPr lang="en-US" sz="1800" dirty="0">
                 <a:solidFill>
@@ -5736,11 +5542,6 @@
               </a:rPr>
               <a:t>Complementary, Not Competing</a:t>
             </a:r>
-            <a:pPr>
-              <a:lnSpc>
-                <a:spcPct val="140000"/>
-              </a:lnSpc>
-            </a:pPr>
             <a:r>
               <a:rPr lang="en-US" sz="1800" dirty="0">
                 <a:solidFill>
@@ -5854,11 +5655,6 @@
               </a:rPr>
               <a:t>Generalization Gap</a:t>
             </a:r>
-            <a:pPr>
-              <a:lnSpc>
-                <a:spcPct val="140000"/>
-              </a:lnSpc>
-            </a:pPr>
             <a:r>
               <a:rPr lang="en-US" sz="1800" dirty="0">
                 <a:solidFill>
@@ -5972,11 +5768,6 @@
               </a:rPr>
               <a:t>The Adversarial Paradox</a:t>
             </a:r>
-            <a:pPr>
-              <a:lnSpc>
-                <a:spcPct val="140000"/>
-              </a:lnSpc>
-            </a:pPr>
             <a:r>
               <a:rPr lang="en-US" sz="1800" dirty="0">
                 <a:solidFill>
@@ -6029,11 +5820,6 @@
               </a:rPr>
               <a:t>Bottom line:</a:t>
             </a:r>
-            <a:pPr>
-              <a:lnSpc>
-                <a:spcPct val="140000"/>
-              </a:lnSpc>
-            </a:pPr>
             <a:r>
               <a:rPr lang="en-US" sz="1800" dirty="0">
                 <a:solidFill>
@@ -6045,11 +5831,6 @@
               </a:rPr>
               <a:t> LLM text is more </a:t>
             </a:r>
-            <a:pPr>
-              <a:lnSpc>
-                <a:spcPct val="140000"/>
-              </a:lnSpc>
-            </a:pPr>
             <a:r>
               <a:rPr lang="en-US" sz="1800" b="1" dirty="0">
                 <a:solidFill>
@@ -6061,11 +5842,6 @@
               </a:rPr>
               <a:t>regular, formulaic, assertive,</a:t>
             </a:r>
-            <a:pPr>
-              <a:lnSpc>
-                <a:spcPct val="140000"/>
-              </a:lnSpc>
-            </a:pPr>
             <a:r>
               <a:rPr lang="en-US" sz="1800" dirty="0">
                 <a:solidFill>
@@ -6077,11 +5853,6 @@
               </a:rPr>
               <a:t> and </a:t>
             </a:r>
-            <a:pPr>
-              <a:lnSpc>
-                <a:spcPct val="140000"/>
-              </a:lnSpc>
-            </a:pPr>
             <a:r>
               <a:rPr lang="en-US" sz="1800" b="1" dirty="0">
                 <a:solidFill>
@@ -6093,11 +5864,6 @@
               </a:rPr>
               <a:t>less cautious</a:t>
             </a:r>
-            <a:pPr>
-              <a:lnSpc>
-                <a:spcPct val="140000"/>
-              </a:lnSpc>
-            </a:pPr>
             <a:r>
               <a:rPr lang="en-US" sz="1800" dirty="0">
                 <a:solidFill>
@@ -6159,10 +5925,18 @@
   <p:clrMapOvr>
     <a:masterClrMapping/>
   </p:clrMapOvr>
-  <p:transition>
-    <p:fade/>
-    <p:spd val="med"/>
-  </p:transition>
+  <mc:AlternateContent xmlns:mc="http://schemas.openxmlformats.org/markup-compatibility/2006">
+    <mc:Choice xmlns:p159="http://schemas.microsoft.com/office/powerpoint/2015/09/main" Requires="p159">
+      <p:transition spd="slow">
+        <p159:morph option="byObject"/>
+      </p:transition>
+    </mc:Choice>
+    <mc:Fallback>
+      <p:transition spd="slow">
+        <p:fade/>
+      </p:transition>
+    </mc:Fallback>
+  </mc:AlternateContent>
 </p:sld>
 </file>
 
@@ -6174,6 +5948,7 @@
         <a:solidFill>
           <a:srgbClr val="F5F5F0"/>
         </a:solidFill>
+        <a:effectLst/>
       </p:bgPr>
     </p:bg>
     <p:spTree>
@@ -6247,11 +6022,6 @@
               </a:rPr>
               <a:t>Introduction | Methodology | Thematic Analysis | </a:t>
             </a:r>
-            <a:pPr algn="ctr">
-              <a:lnSpc>
-                <a:spcPct val="100000"/>
-              </a:lnSpc>
-            </a:pPr>
             <a:r>
               <a:rPr lang="en-US" sz="1200" b="1" dirty="0">
                 <a:solidFill>
@@ -6263,11 +6033,6 @@
               </a:rPr>
               <a:t>Key Findings</a:t>
             </a:r>
-            <a:pPr algn="ctr">
-              <a:lnSpc>
-                <a:spcPct val="100000"/>
-              </a:lnSpc>
-            </a:pPr>
             <a:r>
               <a:rPr lang="en-US" sz="1200" dirty="0">
                 <a:solidFill>
@@ -6367,9 +6132,27 @@
             <a:tbl>
               <a:tblPr/>
               <a:tblGrid>
-                <a:gridCol w="4419600"/>
-                <a:gridCol w="5156200"/>
-                <a:gridCol w="5156200"/>
+                <a:gridCol w="4419600">
+                  <a:extLst>
+                    <a:ext uri="{9D8B030D-6E8A-4147-A177-3AD203B41FA5}">
+                      <a16:colId xmlns:a16="http://schemas.microsoft.com/office/drawing/2014/main" val="20000"/>
+                    </a:ext>
+                  </a:extLst>
+                </a:gridCol>
+                <a:gridCol w="5156200">
+                  <a:extLst>
+                    <a:ext uri="{9D8B030D-6E8A-4147-A177-3AD203B41FA5}">
+                      <a16:colId xmlns:a16="http://schemas.microsoft.com/office/drawing/2014/main" val="20001"/>
+                    </a:ext>
+                  </a:extLst>
+                </a:gridCol>
+                <a:gridCol w="5156200">
+                  <a:extLst>
+                    <a:ext uri="{9D8B030D-6E8A-4147-A177-3AD203B41FA5}">
+                      <a16:colId xmlns:a16="http://schemas.microsoft.com/office/drawing/2014/main" val="20002"/>
+                    </a:ext>
+                  </a:extLst>
+                </a:gridCol>
               </a:tblGrid>
               <a:tr h="619125">
                 <a:tc>
@@ -6396,7 +6179,7 @@
                       </a:endParaRPr>
                     </a:p>
                   </a:txBody>
-                  <a:tcPr marL="91440" marR="91440" marT="0" marB="0" anchor="ctr">
+                  <a:tcPr marT="0" marB="0" anchor="ctr">
                     <a:lnL w="12700" cap="flat" cmpd="sng" algn="ctr">
                       <a:solidFill>
                         <a:srgbClr val="D0D5D2"/>
@@ -6462,7 +6245,7 @@
                       </a:endParaRPr>
                     </a:p>
                   </a:txBody>
-                  <a:tcPr marL="91440" marR="91440" marT="0" marB="0" anchor="ctr">
+                  <a:tcPr marT="0" marB="0" anchor="ctr">
                     <a:lnL w="12700" cap="flat" cmpd="sng" algn="ctr">
                       <a:solidFill>
                         <a:srgbClr val="D0D5D2"/>
@@ -6528,7 +6311,7 @@
                       </a:endParaRPr>
                     </a:p>
                   </a:txBody>
-                  <a:tcPr marL="91440" marR="91440" marT="0" marB="0" anchor="ctr">
+                  <a:tcPr marT="0" marB="0" anchor="ctr">
                     <a:lnL w="12700" cap="flat" cmpd="sng" algn="ctr">
                       <a:solidFill>
                         <a:srgbClr val="D0D5D2"/>
@@ -6570,6 +6353,11 @@
                     </a:solidFill>
                   </a:tcPr>
                 </a:tc>
+                <a:extLst>
+                  <a:ext uri="{0D108BD9-81ED-4DB2-BD59-A6C34878D82A}">
+                    <a16:rowId xmlns:a16="http://schemas.microsoft.com/office/drawing/2014/main" val="10000"/>
+                  </a:ext>
+                </a:extLst>
               </a:tr>
               <a:tr h="619125">
                 <a:tc>
@@ -6596,7 +6384,7 @@
                       </a:endParaRPr>
                     </a:p>
                   </a:txBody>
-                  <a:tcPr marL="91440" marR="91440" marT="0" marB="0" anchor="ctr">
+                  <a:tcPr marT="0" marB="0" anchor="ctr">
                     <a:lnL w="12700" cap="flat" cmpd="sng" algn="ctr">
                       <a:solidFill>
                         <a:srgbClr val="D0D5D2"/>
@@ -6662,7 +6450,7 @@
                       </a:endParaRPr>
                     </a:p>
                   </a:txBody>
-                  <a:tcPr marL="91440" marR="91440" marT="0" marB="0" anchor="ctr">
+                  <a:tcPr marT="0" marB="0" anchor="ctr">
                     <a:lnL w="12700" cap="flat" cmpd="sng" algn="ctr">
                       <a:solidFill>
                         <a:srgbClr val="D0D5D2"/>
@@ -6728,7 +6516,7 @@
                       </a:endParaRPr>
                     </a:p>
                   </a:txBody>
-                  <a:tcPr marL="91440" marR="91440" marT="0" marB="0" anchor="ctr">
+                  <a:tcPr marT="0" marB="0" anchor="ctr">
                     <a:lnL w="12700" cap="flat" cmpd="sng" algn="ctr">
                       <a:solidFill>
                         <a:srgbClr val="D0D5D2"/>
@@ -6770,6 +6558,11 @@
                     </a:solidFill>
                   </a:tcPr>
                 </a:tc>
+                <a:extLst>
+                  <a:ext uri="{0D108BD9-81ED-4DB2-BD59-A6C34878D82A}">
+                    <a16:rowId xmlns:a16="http://schemas.microsoft.com/office/drawing/2014/main" val="10001"/>
+                  </a:ext>
+                </a:extLst>
               </a:tr>
               <a:tr h="619125">
                 <a:tc>
@@ -6796,7 +6589,7 @@
                       </a:endParaRPr>
                     </a:p>
                   </a:txBody>
-                  <a:tcPr marL="91440" marR="91440" marT="0" marB="0" anchor="ctr">
+                  <a:tcPr marT="0" marB="0" anchor="ctr">
                     <a:lnL w="12700" cap="flat" cmpd="sng" algn="ctr">
                       <a:solidFill>
                         <a:srgbClr val="D0D5D2"/>
@@ -6862,7 +6655,7 @@
                       </a:endParaRPr>
                     </a:p>
                   </a:txBody>
-                  <a:tcPr marL="91440" marR="91440" marT="0" marB="0" anchor="ctr">
+                  <a:tcPr marT="0" marB="0" anchor="ctr">
                     <a:lnL w="12700" cap="flat" cmpd="sng" algn="ctr">
                       <a:solidFill>
                         <a:srgbClr val="D0D5D2"/>
@@ -6928,7 +6721,7 @@
                       </a:endParaRPr>
                     </a:p>
                   </a:txBody>
-                  <a:tcPr marL="91440" marR="91440" marT="0" marB="0" anchor="ctr">
+                  <a:tcPr marT="0" marB="0" anchor="ctr">
                     <a:lnL w="12700" cap="flat" cmpd="sng" algn="ctr">
                       <a:solidFill>
                         <a:srgbClr val="D0D5D2"/>
@@ -6970,6 +6763,11 @@
                     </a:solidFill>
                   </a:tcPr>
                 </a:tc>
+                <a:extLst>
+                  <a:ext uri="{0D108BD9-81ED-4DB2-BD59-A6C34878D82A}">
+                    <a16:rowId xmlns:a16="http://schemas.microsoft.com/office/drawing/2014/main" val="10002"/>
+                  </a:ext>
+                </a:extLst>
               </a:tr>
               <a:tr h="619125">
                 <a:tc>
@@ -6996,7 +6794,7 @@
                       </a:endParaRPr>
                     </a:p>
                   </a:txBody>
-                  <a:tcPr marL="91440" marR="91440" marT="0" marB="0" anchor="ctr">
+                  <a:tcPr marT="0" marB="0" anchor="ctr">
                     <a:lnL w="12700" cap="flat" cmpd="sng" algn="ctr">
                       <a:solidFill>
                         <a:srgbClr val="D0D5D2"/>
@@ -7062,7 +6860,7 @@
                       </a:endParaRPr>
                     </a:p>
                   </a:txBody>
-                  <a:tcPr marL="91440" marR="91440" marT="0" marB="0" anchor="ctr">
+                  <a:tcPr marT="0" marB="0" anchor="ctr">
                     <a:lnL w="12700" cap="flat" cmpd="sng" algn="ctr">
                       <a:solidFill>
                         <a:srgbClr val="D0D5D2"/>
@@ -7128,7 +6926,7 @@
                       </a:endParaRPr>
                     </a:p>
                   </a:txBody>
-                  <a:tcPr marL="91440" marR="91440" marT="0" marB="0" anchor="ctr">
+                  <a:tcPr marT="0" marB="0" anchor="ctr">
                     <a:lnL w="12700" cap="flat" cmpd="sng" algn="ctr">
                       <a:solidFill>
                         <a:srgbClr val="D0D5D2"/>
@@ -7170,6 +6968,11 @@
                     </a:solidFill>
                   </a:tcPr>
                 </a:tc>
+                <a:extLst>
+                  <a:ext uri="{0D108BD9-81ED-4DB2-BD59-A6C34878D82A}">
+                    <a16:rowId xmlns:a16="http://schemas.microsoft.com/office/drawing/2014/main" val="10003"/>
+                  </a:ext>
+                </a:extLst>
               </a:tr>
               <a:tr h="619125">
                 <a:tc>
@@ -7196,7 +6999,7 @@
                       </a:endParaRPr>
                     </a:p>
                   </a:txBody>
-                  <a:tcPr marL="91440" marR="91440" marT="0" marB="0" anchor="ctr">
+                  <a:tcPr marT="0" marB="0" anchor="ctr">
                     <a:lnL w="12700" cap="flat" cmpd="sng" algn="ctr">
                       <a:solidFill>
                         <a:srgbClr val="D0D5D2"/>
@@ -7262,7 +7065,7 @@
                       </a:endParaRPr>
                     </a:p>
                   </a:txBody>
-                  <a:tcPr marL="91440" marR="91440" marT="0" marB="0" anchor="ctr">
+                  <a:tcPr marT="0" marB="0" anchor="ctr">
                     <a:lnL w="12700" cap="flat" cmpd="sng" algn="ctr">
                       <a:solidFill>
                         <a:srgbClr val="D0D5D2"/>
@@ -7328,7 +7131,7 @@
                       </a:endParaRPr>
                     </a:p>
                   </a:txBody>
-                  <a:tcPr marL="91440" marR="91440" marT="0" marB="0" anchor="ctr">
+                  <a:tcPr marT="0" marB="0" anchor="ctr">
                     <a:lnL w="12700" cap="flat" cmpd="sng" algn="ctr">
                       <a:solidFill>
                         <a:srgbClr val="D0D5D2"/>
@@ -7370,6 +7173,11 @@
                     </a:solidFill>
                   </a:tcPr>
                 </a:tc>
+                <a:extLst>
+                  <a:ext uri="{0D108BD9-81ED-4DB2-BD59-A6C34878D82A}">
+                    <a16:rowId xmlns:a16="http://schemas.microsoft.com/office/drawing/2014/main" val="10004"/>
+                  </a:ext>
+                </a:extLst>
               </a:tr>
               <a:tr h="619125">
                 <a:tc>
@@ -7396,7 +7204,7 @@
                       </a:endParaRPr>
                     </a:p>
                   </a:txBody>
-                  <a:tcPr marL="91440" marR="91440" marT="0" marB="0" anchor="ctr">
+                  <a:tcPr marT="0" marB="0" anchor="ctr">
                     <a:lnL w="12700" cap="flat" cmpd="sng" algn="ctr">
                       <a:solidFill>
                         <a:srgbClr val="D0D5D2"/>
@@ -7462,7 +7270,7 @@
                       </a:endParaRPr>
                     </a:p>
                   </a:txBody>
-                  <a:tcPr marL="91440" marR="91440" marT="0" marB="0" anchor="ctr">
+                  <a:tcPr marT="0" marB="0" anchor="ctr">
                     <a:lnL w="12700" cap="flat" cmpd="sng" algn="ctr">
                       <a:solidFill>
                         <a:srgbClr val="D0D5D2"/>
@@ -7528,7 +7336,7 @@
                       </a:endParaRPr>
                     </a:p>
                   </a:txBody>
-                  <a:tcPr marL="91440" marR="91440" marT="0" marB="0" anchor="ctr">
+                  <a:tcPr marT="0" marB="0" anchor="ctr">
                     <a:lnL w="12700" cap="flat" cmpd="sng" algn="ctr">
                       <a:solidFill>
                         <a:srgbClr val="D0D5D2"/>
@@ -7570,6 +7378,11 @@
                     </a:solidFill>
                   </a:tcPr>
                 </a:tc>
+                <a:extLst>
+                  <a:ext uri="{0D108BD9-81ED-4DB2-BD59-A6C34878D82A}">
+                    <a16:rowId xmlns:a16="http://schemas.microsoft.com/office/drawing/2014/main" val="10005"/>
+                  </a:ext>
+                </a:extLst>
               </a:tr>
               <a:tr h="619125">
                 <a:tc>
@@ -7596,7 +7409,7 @@
                       </a:endParaRPr>
                     </a:p>
                   </a:txBody>
-                  <a:tcPr marL="91440" marR="91440" marT="0" marB="0" anchor="ctr">
+                  <a:tcPr marT="0" marB="0" anchor="ctr">
                     <a:lnL w="12700" cap="flat" cmpd="sng" algn="ctr">
                       <a:solidFill>
                         <a:srgbClr val="D0D5D2"/>
@@ -7662,7 +7475,7 @@
                       </a:endParaRPr>
                     </a:p>
                   </a:txBody>
-                  <a:tcPr marL="91440" marR="91440" marT="0" marB="0" anchor="ctr">
+                  <a:tcPr marT="0" marB="0" anchor="ctr">
                     <a:lnL w="12700" cap="flat" cmpd="sng" algn="ctr">
                       <a:solidFill>
                         <a:srgbClr val="D0D5D2"/>
@@ -7728,7 +7541,7 @@
                       </a:endParaRPr>
                     </a:p>
                   </a:txBody>
-                  <a:tcPr marL="91440" marR="91440" marT="0" marB="0" anchor="ctr">
+                  <a:tcPr marT="0" marB="0" anchor="ctr">
                     <a:lnL w="12700" cap="flat" cmpd="sng" algn="ctr">
                       <a:solidFill>
                         <a:srgbClr val="D0D5D2"/>
@@ -7770,6 +7583,11 @@
                     </a:solidFill>
                   </a:tcPr>
                 </a:tc>
+                <a:extLst>
+                  <a:ext uri="{0D108BD9-81ED-4DB2-BD59-A6C34878D82A}">
+                    <a16:rowId xmlns:a16="http://schemas.microsoft.com/office/drawing/2014/main" val="10006"/>
+                  </a:ext>
+                </a:extLst>
               </a:tr>
               <a:tr h="619125">
                 <a:tc>
@@ -7796,7 +7614,7 @@
                       </a:endParaRPr>
                     </a:p>
                   </a:txBody>
-                  <a:tcPr marL="91440" marR="91440" marT="0" marB="0" anchor="ctr">
+                  <a:tcPr marT="0" marB="0" anchor="ctr">
                     <a:lnL w="12700" cap="flat" cmpd="sng" algn="ctr">
                       <a:solidFill>
                         <a:srgbClr val="D0D5D2"/>
@@ -7862,7 +7680,7 @@
                       </a:endParaRPr>
                     </a:p>
                   </a:txBody>
-                  <a:tcPr marL="91440" marR="91440" marT="0" marB="0" anchor="ctr">
+                  <a:tcPr marT="0" marB="0" anchor="ctr">
                     <a:lnL w="12700" cap="flat" cmpd="sng" algn="ctr">
                       <a:solidFill>
                         <a:srgbClr val="D0D5D2"/>
@@ -7928,7 +7746,7 @@
                       </a:endParaRPr>
                     </a:p>
                   </a:txBody>
-                  <a:tcPr marL="91440" marR="91440" marT="0" marB="0" anchor="ctr">
+                  <a:tcPr marT="0" marB="0" anchor="ctr">
                     <a:lnL w="12700" cap="flat" cmpd="sng" algn="ctr">
                       <a:solidFill>
                         <a:srgbClr val="D0D5D2"/>
@@ -7970,6 +7788,11 @@
                     </a:solidFill>
                   </a:tcPr>
                 </a:tc>
+                <a:extLst>
+                  <a:ext uri="{0D108BD9-81ED-4DB2-BD59-A6C34878D82A}">
+                    <a16:rowId xmlns:a16="http://schemas.microsoft.com/office/drawing/2014/main" val="10007"/>
+                  </a:ext>
+                </a:extLst>
               </a:tr>
             </a:tbl>
           </a:graphicData>
@@ -8052,11 +7875,6 @@
               </a:rPr>
               <a:t>Insight:</a:t>
             </a:r>
-            <a:pPr>
-              <a:lnSpc>
-                <a:spcPct val="140000"/>
-              </a:lnSpc>
-            </a:pPr>
             <a:r>
               <a:rPr lang="en-US" sz="1800" dirty="0">
                 <a:solidFill>
@@ -8118,10 +7936,18 @@
   <p:clrMapOvr>
     <a:masterClrMapping/>
   </p:clrMapOvr>
-  <p:transition>
-    <p:fade/>
-    <p:spd val="med"/>
-  </p:transition>
+  <mc:AlternateContent xmlns:mc="http://schemas.openxmlformats.org/markup-compatibility/2006">
+    <mc:Choice xmlns:p159="http://schemas.microsoft.com/office/powerpoint/2015/09/main" Requires="p159">
+      <p:transition spd="slow">
+        <p159:morph option="byObject"/>
+      </p:transition>
+    </mc:Choice>
+    <mc:Fallback>
+      <p:transition spd="slow">
+        <p:fade/>
+      </p:transition>
+    </mc:Fallback>
+  </mc:AlternateContent>
 </p:sld>
 </file>
 
@@ -8133,6 +7959,7 @@
         <a:solidFill>
           <a:srgbClr val="1B5E3B"/>
         </a:solidFill>
+        <a:effectLst/>
       </p:bgPr>
     </p:bg>
     <p:spTree>
@@ -8301,10 +8128,18 @@
   <p:clrMapOvr>
     <a:masterClrMapping/>
   </p:clrMapOvr>
-  <p:transition>
-    <p:fade/>
-    <p:spd val="med"/>
-  </p:transition>
+  <mc:AlternateContent xmlns:mc="http://schemas.openxmlformats.org/markup-compatibility/2006">
+    <mc:Choice xmlns:p159="http://schemas.microsoft.com/office/powerpoint/2015/09/main" Requires="p159">
+      <p:transition spd="slow">
+        <p159:morph option="byObject"/>
+      </p:transition>
+    </mc:Choice>
+    <mc:Fallback>
+      <p:transition spd="slow">
+        <p:fade/>
+      </p:transition>
+    </mc:Fallback>
+  </mc:AlternateContent>
 </p:sld>
 </file>
 
@@ -8316,6 +8151,7 @@
         <a:solidFill>
           <a:srgbClr val="F5F5F0"/>
         </a:solidFill>
+        <a:effectLst/>
       </p:bgPr>
     </p:bg>
     <p:spTree>
@@ -8389,11 +8225,6 @@
               </a:rPr>
               <a:t>Introduction | Methodology | Thematic Analysis | Key Findings | </a:t>
             </a:r>
-            <a:pPr algn="ctr">
-              <a:lnSpc>
-                <a:spcPct val="100000"/>
-              </a:lnSpc>
-            </a:pPr>
             <a:r>
               <a:rPr lang="en-US" sz="1200" b="1" dirty="0">
                 <a:solidFill>
@@ -9068,12 +8899,37 @@
               </a:rPr>
               <a:t>Immediate:</a:t>
             </a:r>
+            <a:r>
+              <a:rPr lang="en-US" sz="1500" dirty="0">
+                <a:solidFill>
+                  <a:srgbClr val="FFFFFF"/>
+                </a:solidFill>
+                <a:latin typeface="Quattrocento Sans" pitchFamily="34" charset="0"/>
+                <a:ea typeface="Quattrocento Sans" pitchFamily="34" charset="-122"/>
+                <a:cs typeface="Quattrocento Sans" pitchFamily="34" charset="-120"/>
+              </a:rPr>
+              <a:t> Gaps 2, 3, 4 (high urgency, feasible)</a:t>
+            </a:r>
+            <a:endParaRPr lang="en-US" sz="1600" dirty="0"/>
+          </a:p>
+          <a:p>
             <a:pPr>
               <a:lnSpc>
                 <a:spcPct val="140000"/>
               </a:lnSpc>
             </a:pPr>
             <a:r>
+              <a:rPr lang="en-US" sz="1500" b="1" dirty="0">
+                <a:solidFill>
+                  <a:srgbClr val="FFFFFF"/>
+                </a:solidFill>
+                <a:latin typeface="Quattrocento Sans" pitchFamily="34" charset="0"/>
+                <a:ea typeface="Quattrocento Sans" pitchFamily="34" charset="-122"/>
+                <a:cs typeface="Quattrocento Sans" pitchFamily="34" charset="-120"/>
+              </a:rPr>
+              <a:t>Near-term:</a:t>
+            </a:r>
+            <a:r>
               <a:rPr lang="en-US" sz="1500" dirty="0">
                 <a:solidFill>
                   <a:srgbClr val="FFFFFF"/>
@@ -9082,7 +8938,7 @@
                 <a:ea typeface="Quattrocento Sans" pitchFamily="34" charset="-122"/>
                 <a:cs typeface="Quattrocento Sans" pitchFamily="34" charset="-120"/>
               </a:rPr>
-              <a:t> Gaps 2, 3, 4 (high urgency, feasible)</a:t>
+              <a:t> Gap 5 (multilingual benchmarks)</a:t>
             </a:r>
             <a:endParaRPr lang="en-US" sz="1600" dirty="0"/>
           </a:p>
@@ -9101,48 +8957,8 @@
                 <a:ea typeface="Quattrocento Sans" pitchFamily="34" charset="-122"/>
                 <a:cs typeface="Quattrocento Sans" pitchFamily="34" charset="-120"/>
               </a:rPr>
-              <a:t>Near-term:</a:t>
-            </a:r>
-            <a:pPr>
-              <a:lnSpc>
-                <a:spcPct val="140000"/>
-              </a:lnSpc>
-            </a:pPr>
-            <a:r>
-              <a:rPr lang="en-US" sz="1500" dirty="0">
-                <a:solidFill>
-                  <a:srgbClr val="FFFFFF"/>
-                </a:solidFill>
-                <a:latin typeface="Quattrocento Sans" pitchFamily="34" charset="0"/>
-                <a:ea typeface="Quattrocento Sans" pitchFamily="34" charset="-122"/>
-                <a:cs typeface="Quattrocento Sans" pitchFamily="34" charset="-120"/>
-              </a:rPr>
-              <a:t> Gap 5 (multilingual benchmarks)</a:t>
-            </a:r>
-            <a:endParaRPr lang="en-US" sz="1600" dirty="0"/>
-          </a:p>
-          <a:p>
-            <a:pPr>
-              <a:lnSpc>
-                <a:spcPct val="140000"/>
-              </a:lnSpc>
-            </a:pPr>
-            <a:r>
-              <a:rPr lang="en-US" sz="1500" b="1" dirty="0">
-                <a:solidFill>
-                  <a:srgbClr val="FFFFFF"/>
-                </a:solidFill>
-                <a:latin typeface="Quattrocento Sans" pitchFamily="34" charset="0"/>
-                <a:ea typeface="Quattrocento Sans" pitchFamily="34" charset="-122"/>
-                <a:cs typeface="Quattrocento Sans" pitchFamily="34" charset="-120"/>
-              </a:rPr>
               <a:t>Long-term:</a:t>
             </a:r>
-            <a:pPr>
-              <a:lnSpc>
-                <a:spcPct val="140000"/>
-              </a:lnSpc>
-            </a:pPr>
             <a:r>
               <a:rPr lang="en-US" sz="1500" dirty="0">
                 <a:solidFill>
@@ -9204,10 +9020,18 @@
   <p:clrMapOvr>
     <a:masterClrMapping/>
   </p:clrMapOvr>
-  <p:transition>
-    <p:fade/>
-    <p:spd val="med"/>
-  </p:transition>
+  <mc:AlternateContent xmlns:mc="http://schemas.openxmlformats.org/markup-compatibility/2006">
+    <mc:Choice xmlns:p159="http://schemas.microsoft.com/office/powerpoint/2015/09/main" Requires="p159">
+      <p:transition spd="slow">
+        <p159:morph option="byObject"/>
+      </p:transition>
+    </mc:Choice>
+    <mc:Fallback>
+      <p:transition spd="slow">
+        <p:fade/>
+      </p:transition>
+    </mc:Fallback>
+  </mc:AlternateContent>
 </p:sld>
 </file>
 
@@ -9219,6 +9043,7 @@
         <a:solidFill>
           <a:srgbClr val="F5F5F0"/>
         </a:solidFill>
+        <a:effectLst/>
       </p:bgPr>
     </p:bg>
     <p:spTree>
@@ -9292,11 +9117,6 @@
               </a:rPr>
               <a:t>Introduction | Methodology | Thematic Analysis | Key Findings | </a:t>
             </a:r>
-            <a:pPr algn="ctr">
-              <a:lnSpc>
-                <a:spcPct val="100000"/>
-              </a:lnSpc>
-            </a:pPr>
             <a:r>
               <a:rPr lang="en-US" sz="1200" b="1" dirty="0">
                 <a:solidFill>
@@ -9491,11 +9311,6 @@
               </a:rPr>
               <a:t>Convergent Validity</a:t>
             </a:r>
-            <a:pPr>
-              <a:lnSpc>
-                <a:spcPct val="150000"/>
-              </a:lnSpc>
-            </a:pPr>
             <a:r>
               <a:rPr lang="en-US" sz="1800" dirty="0">
                 <a:solidFill>
@@ -9629,11 +9444,6 @@
               </a:rPr>
               <a:t>The field has </a:t>
             </a:r>
-            <a:pPr>
-              <a:lnSpc>
-                <a:spcPct val="150000"/>
-              </a:lnSpc>
-            </a:pPr>
             <a:r>
               <a:rPr lang="en-US" sz="1800" b="1" dirty="0">
                 <a:solidFill>
@@ -9645,11 +9455,6 @@
               </a:rPr>
               <a:t>not yet reconciled transparency with robustness</a:t>
             </a:r>
-            <a:pPr>
-              <a:lnSpc>
-                <a:spcPct val="150000"/>
-              </a:lnSpc>
-            </a:pPr>
             <a:r>
               <a:rPr lang="en-US" sz="1800" dirty="0">
                 <a:solidFill>
@@ -9748,14 +9553,6 @@
               </a:rPr>
               <a:t>Accuracy alone is insufficient</a:t>
             </a:r>
-            <a:pPr>
-              <a:lnSpc>
-                <a:spcPct val="160000"/>
-              </a:lnSpc>
-              <a:spcBef>
-                <a:spcPts val="10"/>
-              </a:spcBef>
-            </a:pPr>
             <a:r>
               <a:rPr lang="en-US" sz="1800" dirty="0">
                 <a:solidFill>
@@ -9791,14 +9588,6 @@
               </a:rPr>
               <a:t>Explainability quality</a:t>
             </a:r>
-            <a:pPr>
-              <a:lnSpc>
-                <a:spcPct val="160000"/>
-              </a:lnSpc>
-              <a:spcBef>
-                <a:spcPts val="10"/>
-              </a:spcBef>
-            </a:pPr>
             <a:r>
               <a:rPr lang="en-US" sz="1800" dirty="0">
                 <a:solidFill>
@@ -9834,14 +9623,6 @@
               </a:rPr>
               <a:t>Evaluation must cover</a:t>
             </a:r>
-            <a:pPr>
-              <a:lnSpc>
-                <a:spcPct val="160000"/>
-              </a:lnSpc>
-              <a:spcBef>
-                <a:spcPts val="10"/>
-              </a:spcBef>
-            </a:pPr>
             <a:r>
               <a:rPr lang="en-US" sz="1800" dirty="0">
                 <a:solidFill>
@@ -9877,14 +9658,6 @@
               </a:rPr>
               <a:t>Adversarial robustness</a:t>
             </a:r>
-            <a:pPr>
-              <a:lnSpc>
-                <a:spcPct val="160000"/>
-              </a:lnSpc>
-              <a:spcBef>
-                <a:spcPts val="10"/>
-              </a:spcBef>
-            </a:pPr>
             <a:r>
               <a:rPr lang="en-US" sz="1800" dirty="0">
                 <a:solidFill>
@@ -9987,10 +9760,18 @@
   <p:clrMapOvr>
     <a:masterClrMapping/>
   </p:clrMapOvr>
-  <p:transition>
-    <p:fade/>
-    <p:spd val="med"/>
-  </p:transition>
+  <mc:AlternateContent xmlns:mc="http://schemas.openxmlformats.org/markup-compatibility/2006">
+    <mc:Choice xmlns:p159="http://schemas.microsoft.com/office/powerpoint/2015/09/main" Requires="p159">
+      <p:transition spd="slow">
+        <p159:morph option="byObject"/>
+      </p:transition>
+    </mc:Choice>
+    <mc:Fallback>
+      <p:transition spd="slow">
+        <p:fade/>
+      </p:transition>
+    </mc:Fallback>
+  </mc:AlternateContent>
 </p:sld>
 </file>
 
@@ -10002,6 +9783,7 @@
         <a:solidFill>
           <a:srgbClr val="1B5E3B"/>
         </a:solidFill>
+        <a:effectLst/>
       </p:bgPr>
     </p:bg>
     <p:spTree>
@@ -10231,10 +10013,18 @@
   <p:clrMapOvr>
     <a:masterClrMapping/>
   </p:clrMapOvr>
-  <p:transition>
-    <p:fade/>
-    <p:spd val="med"/>
-  </p:transition>
+  <mc:AlternateContent xmlns:mc="http://schemas.openxmlformats.org/markup-compatibility/2006">
+    <mc:Choice xmlns:p159="http://schemas.microsoft.com/office/powerpoint/2015/09/main" Requires="p159">
+      <p:transition spd="slow">
+        <p159:morph option="byObject"/>
+      </p:transition>
+    </mc:Choice>
+    <mc:Fallback>
+      <p:transition spd="slow">
+        <p:fade/>
+      </p:transition>
+    </mc:Fallback>
+  </mc:AlternateContent>
 </p:sld>
 </file>
 
@@ -10246,6 +10036,7 @@
         <a:solidFill>
           <a:srgbClr val="F5F5F0"/>
         </a:solidFill>
+        <a:effectLst/>
       </p:bgPr>
     </p:bg>
     <p:spTree>
@@ -11004,10 +10795,18 @@
   <p:clrMapOvr>
     <a:masterClrMapping/>
   </p:clrMapOvr>
-  <p:transition>
-    <p:fade/>
-    <p:spd val="med"/>
-  </p:transition>
+  <mc:AlternateContent xmlns:mc="http://schemas.openxmlformats.org/markup-compatibility/2006">
+    <mc:Choice xmlns:p159="http://schemas.microsoft.com/office/powerpoint/2015/09/main" Requires="p159">
+      <p:transition spd="slow">
+        <p159:morph option="byObject"/>
+      </p:transition>
+    </mc:Choice>
+    <mc:Fallback>
+      <p:transition spd="slow">
+        <p:fade/>
+      </p:transition>
+    </mc:Fallback>
+  </mc:AlternateContent>
 </p:sld>
 </file>
 
@@ -11019,6 +10818,7 @@
         <a:solidFill>
           <a:srgbClr val="1B5E3B"/>
         </a:solidFill>
+        <a:effectLst/>
       </p:bgPr>
     </p:bg>
     <p:spTree>
@@ -11187,10 +10987,18 @@
   <p:clrMapOvr>
     <a:masterClrMapping/>
   </p:clrMapOvr>
-  <p:transition>
-    <p:fade/>
-    <p:spd val="med"/>
-  </p:transition>
+  <mc:AlternateContent xmlns:mc="http://schemas.openxmlformats.org/markup-compatibility/2006">
+    <mc:Choice xmlns:p159="http://schemas.microsoft.com/office/powerpoint/2015/09/main" Requires="p159">
+      <p:transition spd="slow">
+        <p159:morph option="byObject"/>
+      </p:transition>
+    </mc:Choice>
+    <mc:Fallback>
+      <p:transition spd="slow">
+        <p:fade/>
+      </p:transition>
+    </mc:Fallback>
+  </mc:AlternateContent>
 </p:sld>
 </file>
 
@@ -11202,6 +11010,7 @@
         <a:solidFill>
           <a:srgbClr val="F5F5F0"/>
         </a:solidFill>
+        <a:effectLst/>
       </p:bgPr>
     </p:bg>
     <p:spTree>
@@ -11275,11 +11084,6 @@
               </a:rPr>
               <a:t>Introduction</a:t>
             </a:r>
-            <a:pPr algn="ctr">
-              <a:lnSpc>
-                <a:spcPct val="100000"/>
-              </a:lnSpc>
-            </a:pPr>
             <a:r>
               <a:rPr lang="en-US" sz="1200" dirty="0">
                 <a:solidFill>
@@ -11393,11 +11197,6 @@
               </a:rPr>
               <a:t>Large Language Models</a:t>
             </a:r>
-            <a:pPr>
-              <a:lnSpc>
-                <a:spcPct val="150000"/>
-              </a:lnSpc>
-            </a:pPr>
             <a:r>
               <a:rPr lang="en-US" sz="2000" dirty="0">
                 <a:solidFill>
@@ -11455,14 +11254,6 @@
               </a:rPr>
               <a:t>Academia</a:t>
             </a:r>
-            <a:pPr>
-              <a:lnSpc>
-                <a:spcPct val="150000"/>
-              </a:lnSpc>
-              <a:spcBef>
-                <a:spcPts val="10"/>
-              </a:spcBef>
-            </a:pPr>
             <a:r>
               <a:rPr lang="en-US" sz="2000" dirty="0">
                 <a:solidFill>
@@ -11498,14 +11289,6 @@
               </a:rPr>
               <a:t>Journalism</a:t>
             </a:r>
-            <a:pPr>
-              <a:lnSpc>
-                <a:spcPct val="150000"/>
-              </a:lnSpc>
-              <a:spcBef>
-                <a:spcPts val="10"/>
-              </a:spcBef>
-            </a:pPr>
             <a:r>
               <a:rPr lang="en-US" sz="2000" dirty="0">
                 <a:solidFill>
@@ -11541,14 +11324,6 @@
               </a:rPr>
               <a:t>Law</a:t>
             </a:r>
-            <a:pPr>
-              <a:lnSpc>
-                <a:spcPct val="150000"/>
-              </a:lnSpc>
-              <a:spcBef>
-                <a:spcPts val="10"/>
-              </a:spcBef>
-            </a:pPr>
             <a:r>
               <a:rPr lang="en-US" sz="2000" dirty="0">
                 <a:solidFill>
@@ -11584,14 +11359,6 @@
               </a:rPr>
               <a:t>Medicine</a:t>
             </a:r>
-            <a:pPr>
-              <a:lnSpc>
-                <a:spcPct val="150000"/>
-              </a:lnSpc>
-              <a:spcBef>
-                <a:spcPts val="10"/>
-              </a:spcBef>
-            </a:pPr>
             <a:r>
               <a:rPr lang="en-US" sz="2000" dirty="0">
                 <a:solidFill>
@@ -11625,14 +11392,6 @@
               </a:rPr>
               <a:t>Early detectors used </a:t>
             </a:r>
-            <a:pPr>
-              <a:lnSpc>
-                <a:spcPct val="150000"/>
-              </a:lnSpc>
-              <a:spcBef>
-                <a:spcPts val="1200"/>
-              </a:spcBef>
-            </a:pPr>
             <a:r>
               <a:rPr lang="en-US" sz="2000" b="1" dirty="0">
                 <a:solidFill>
@@ -11644,14 +11403,6 @@
               </a:rPr>
               <a:t>perplexity scores</a:t>
             </a:r>
-            <a:pPr>
-              <a:lnSpc>
-                <a:spcPct val="150000"/>
-              </a:lnSpc>
-              <a:spcBef>
-                <a:spcPts val="1200"/>
-              </a:spcBef>
-            </a:pPr>
             <a:r>
               <a:rPr lang="en-US" sz="2000" dirty="0">
                 <a:solidFill>
@@ -11663,14 +11414,6 @@
               </a:rPr>
               <a:t> and </a:t>
             </a:r>
-            <a:pPr>
-              <a:lnSpc>
-                <a:spcPct val="150000"/>
-              </a:lnSpc>
-              <a:spcBef>
-                <a:spcPts val="1200"/>
-              </a:spcBef>
-            </a:pPr>
             <a:r>
               <a:rPr lang="en-US" sz="2000" b="1" dirty="0">
                 <a:solidFill>
@@ -11682,14 +11425,6 @@
               </a:rPr>
               <a:t>stylometric</a:t>
             </a:r>
-            <a:pPr>
-              <a:lnSpc>
-                <a:spcPct val="150000"/>
-              </a:lnSpc>
-              <a:spcBef>
-                <a:spcPts val="1200"/>
-              </a:spcBef>
-            </a:pPr>
             <a:r>
               <a:rPr lang="en-US" sz="2000" dirty="0">
                 <a:solidFill>
@@ -11701,14 +11436,6 @@
               </a:rPr>
               <a:t> features. Modern systems use </a:t>
             </a:r>
-            <a:pPr>
-              <a:lnSpc>
-                <a:spcPct val="150000"/>
-              </a:lnSpc>
-              <a:spcBef>
-                <a:spcPts val="1200"/>
-              </a:spcBef>
-            </a:pPr>
             <a:r>
               <a:rPr lang="en-US" sz="2000" b="1" dirty="0">
                 <a:solidFill>
@@ -11720,14 +11447,6 @@
               </a:rPr>
               <a:t>transformers</a:t>
             </a:r>
-            <a:pPr>
-              <a:lnSpc>
-                <a:spcPct val="150000"/>
-              </a:lnSpc>
-              <a:spcBef>
-                <a:spcPts val="1200"/>
-              </a:spcBef>
-            </a:pPr>
             <a:r>
               <a:rPr lang="en-US" sz="2000" dirty="0">
                 <a:solidFill>
@@ -11739,14 +11458,6 @@
               </a:rPr>
               <a:t> (RoBERTa, DistilBERT) for higher accuracy — but they act as </a:t>
             </a:r>
-            <a:pPr>
-              <a:lnSpc>
-                <a:spcPct val="150000"/>
-              </a:lnSpc>
-              <a:spcBef>
-                <a:spcPts val="1200"/>
-              </a:spcBef>
-            </a:pPr>
             <a:r>
               <a:rPr lang="en-US" sz="2000" b="1" dirty="0">
                 <a:solidFill>
@@ -11839,11 +11550,6 @@
               </a:rPr>
               <a:t>Key Message:</a:t>
             </a:r>
-            <a:pPr>
-              <a:lnSpc>
-                <a:spcPct val="140000"/>
-              </a:lnSpc>
-            </a:pPr>
             <a:r>
               <a:rPr lang="en-US" sz="1800" dirty="0">
                 <a:solidFill>
@@ -11855,11 +11561,6 @@
               </a:rPr>
               <a:t> We need detection systems that are not just accurate, but also </a:t>
             </a:r>
-            <a:pPr>
-              <a:lnSpc>
-                <a:spcPct val="140000"/>
-              </a:lnSpc>
-            </a:pPr>
             <a:r>
               <a:rPr lang="en-US" sz="1800" b="1" dirty="0">
                 <a:solidFill>
@@ -11871,11 +11572,6 @@
               </a:rPr>
               <a:t>explainable</a:t>
             </a:r>
-            <a:pPr>
-              <a:lnSpc>
-                <a:spcPct val="140000"/>
-              </a:lnSpc>
-            </a:pPr>
             <a:r>
               <a:rPr lang="en-US" sz="1800" dirty="0">
                 <a:solidFill>
@@ -11887,11 +11583,6 @@
               </a:rPr>
               <a:t> and </a:t>
             </a:r>
-            <a:pPr>
-              <a:lnSpc>
-                <a:spcPct val="140000"/>
-              </a:lnSpc>
-            </a:pPr>
             <a:r>
               <a:rPr lang="en-US" sz="1800" b="1" dirty="0">
                 <a:solidFill>
@@ -11903,11 +11594,6 @@
               </a:rPr>
               <a:t>trustworthy</a:t>
             </a:r>
-            <a:pPr>
-              <a:lnSpc>
-                <a:spcPct val="140000"/>
-              </a:lnSpc>
-            </a:pPr>
             <a:r>
               <a:rPr lang="en-US" sz="1800" dirty="0">
                 <a:solidFill>
@@ -11969,10 +11655,18 @@
   <p:clrMapOvr>
     <a:masterClrMapping/>
   </p:clrMapOvr>
-  <p:transition>
-    <p:fade/>
-    <p:spd val="med"/>
-  </p:transition>
+  <mc:AlternateContent xmlns:mc="http://schemas.openxmlformats.org/markup-compatibility/2006">
+    <mc:Choice xmlns:p159="http://schemas.microsoft.com/office/powerpoint/2015/09/main" Requires="p159">
+      <p:transition spd="slow">
+        <p159:morph option="byObject"/>
+      </p:transition>
+    </mc:Choice>
+    <mc:Fallback>
+      <p:transition spd="slow">
+        <p:fade/>
+      </p:transition>
+    </mc:Fallback>
+  </mc:AlternateContent>
 </p:sld>
 </file>
 
@@ -11984,6 +11678,7 @@
         <a:solidFill>
           <a:srgbClr val="F5F5F0"/>
         </a:solidFill>
+        <a:effectLst/>
       </p:bgPr>
     </p:bg>
     <p:spTree>
@@ -12057,11 +11752,6 @@
               </a:rPr>
               <a:t>Introduction</a:t>
             </a:r>
-            <a:pPr algn="ctr">
-              <a:lnSpc>
-                <a:spcPct val="100000"/>
-              </a:lnSpc>
-            </a:pPr>
             <a:r>
               <a:rPr lang="en-US" sz="1200" dirty="0">
                 <a:solidFill>
@@ -12175,11 +11865,6 @@
               </a:rPr>
               <a:t>XAI</a:t>
             </a:r>
-            <a:pPr>
-              <a:lnSpc>
-                <a:spcPct val="150000"/>
-              </a:lnSpc>
-            </a:pPr>
             <a:r>
               <a:rPr lang="en-US" sz="2000" dirty="0">
                 <a:solidFill>
@@ -12712,11 +12397,6 @@
               </a:rPr>
               <a:t>Both methods answer: </a:t>
             </a:r>
-            <a:pPr>
-              <a:lnSpc>
-                <a:spcPct val="150000"/>
-              </a:lnSpc>
-            </a:pPr>
             <a:r>
               <a:rPr lang="en-US" sz="2000" b="1" dirty="0">
                 <a:solidFill>
@@ -12809,11 +12489,6 @@
               </a:rPr>
               <a:t>Key Message:</a:t>
             </a:r>
-            <a:pPr>
-              <a:lnSpc>
-                <a:spcPct val="140000"/>
-              </a:lnSpc>
-            </a:pPr>
             <a:r>
               <a:rPr lang="en-US" sz="1800" dirty="0">
                 <a:solidFill>
@@ -12825,11 +12500,6 @@
               </a:rPr>
               <a:t> LIME and SHAP help us understand </a:t>
             </a:r>
-            <a:pPr>
-              <a:lnSpc>
-                <a:spcPct val="140000"/>
-              </a:lnSpc>
-            </a:pPr>
             <a:r>
               <a:rPr lang="en-US" sz="1800" b="1" dirty="0">
                 <a:solidFill>
@@ -12841,11 +12511,6 @@
               </a:rPr>
               <a:t>WHY</a:t>
             </a:r>
-            <a:pPr>
-              <a:lnSpc>
-                <a:spcPct val="140000"/>
-              </a:lnSpc>
-            </a:pPr>
             <a:r>
               <a:rPr lang="en-US" sz="1800" dirty="0">
                 <a:solidFill>
@@ -12907,10 +12572,18 @@
   <p:clrMapOvr>
     <a:masterClrMapping/>
   </p:clrMapOvr>
-  <p:transition>
-    <p:fade/>
-    <p:spd val="med"/>
-  </p:transition>
+  <mc:AlternateContent xmlns:mc="http://schemas.openxmlformats.org/markup-compatibility/2006">
+    <mc:Choice xmlns:p159="http://schemas.microsoft.com/office/powerpoint/2015/09/main" Requires="p159">
+      <p:transition spd="slow">
+        <p159:morph option="byObject"/>
+      </p:transition>
+    </mc:Choice>
+    <mc:Fallback>
+      <p:transition spd="slow">
+        <p:fade/>
+      </p:transition>
+    </mc:Fallback>
+  </mc:AlternateContent>
 </p:sld>
 </file>
 
@@ -12922,6 +12595,7 @@
         <a:solidFill>
           <a:srgbClr val="1B5E3B"/>
         </a:solidFill>
+        <a:effectLst/>
       </p:bgPr>
     </p:bg>
     <p:spTree>
@@ -13090,10 +12764,18 @@
   <p:clrMapOvr>
     <a:masterClrMapping/>
   </p:clrMapOvr>
-  <p:transition>
-    <p:fade/>
-    <p:spd val="med"/>
-  </p:transition>
+  <mc:AlternateContent xmlns:mc="http://schemas.openxmlformats.org/markup-compatibility/2006">
+    <mc:Choice xmlns:p159="http://schemas.microsoft.com/office/powerpoint/2015/09/main" Requires="p159">
+      <p:transition spd="slow">
+        <p159:morph option="byObject"/>
+      </p:transition>
+    </mc:Choice>
+    <mc:Fallback>
+      <p:transition spd="slow">
+        <p:fade/>
+      </p:transition>
+    </mc:Fallback>
+  </mc:AlternateContent>
 </p:sld>
 </file>
 
@@ -13105,6 +12787,7 @@
         <a:solidFill>
           <a:srgbClr val="F5F5F0"/>
         </a:solidFill>
+        <a:effectLst/>
       </p:bgPr>
     </p:bg>
     <p:spTree>
@@ -13178,11 +12861,6 @@
               </a:rPr>
               <a:t>Introduction | </a:t>
             </a:r>
-            <a:pPr algn="ctr">
-              <a:lnSpc>
-                <a:spcPct val="100000"/>
-              </a:lnSpc>
-            </a:pPr>
             <a:r>
               <a:rPr lang="en-US" sz="1200" b="1" dirty="0">
                 <a:solidFill>
@@ -13194,11 +12872,6 @@
               </a:rPr>
               <a:t>Methodology</a:t>
             </a:r>
-            <a:pPr algn="ctr">
-              <a:lnSpc>
-                <a:spcPct val="100000"/>
-              </a:lnSpc>
-            </a:pPr>
             <a:r>
               <a:rPr lang="en-US" sz="1200" dirty="0">
                 <a:solidFill>
@@ -14117,7 +13790,7 @@
       </p:sp>
       <p:graphicFrame>
         <p:nvGraphicFramePr>
-          <p:cNvPr id="8" name="Table 0"/>
+          <p:cNvPr id="25" name="Table 0"/>
           <p:cNvGraphicFramePr>
             <a:graphicFrameLocks noGrp="1"/>
           </p:cNvGraphicFramePr>
@@ -14138,9 +13811,27 @@
             <a:tbl>
               <a:tblPr/>
               <a:tblGrid>
-                <a:gridCol w="5156200"/>
-                <a:gridCol w="2209800"/>
-                <a:gridCol w="7366000"/>
+                <a:gridCol w="5156200">
+                  <a:extLst>
+                    <a:ext uri="{9D8B030D-6E8A-4147-A177-3AD203B41FA5}">
+                      <a16:colId xmlns:a16="http://schemas.microsoft.com/office/drawing/2014/main" val="20000"/>
+                    </a:ext>
+                  </a:extLst>
+                </a:gridCol>
+                <a:gridCol w="2209800">
+                  <a:extLst>
+                    <a:ext uri="{9D8B030D-6E8A-4147-A177-3AD203B41FA5}">
+                      <a16:colId xmlns:a16="http://schemas.microsoft.com/office/drawing/2014/main" val="20001"/>
+                    </a:ext>
+                  </a:extLst>
+                </a:gridCol>
+                <a:gridCol w="7366000">
+                  <a:extLst>
+                    <a:ext uri="{9D8B030D-6E8A-4147-A177-3AD203B41FA5}">
+                      <a16:colId xmlns:a16="http://schemas.microsoft.com/office/drawing/2014/main" val="20002"/>
+                    </a:ext>
+                  </a:extLst>
+                </a:gridCol>
               </a:tblGrid>
               <a:tr h="635000">
                 <a:tc>
@@ -14167,7 +13858,7 @@
                       </a:endParaRPr>
                     </a:p>
                   </a:txBody>
-                  <a:tcPr marL="91440" marR="91440" marT="0" marB="0" anchor="ctr">
+                  <a:tcPr marT="0" marB="0" anchor="ctr">
                     <a:lnL w="12700" cap="flat" cmpd="sng" algn="ctr">
                       <a:solidFill>
                         <a:srgbClr val="D0D5D2"/>
@@ -14233,7 +13924,7 @@
                       </a:endParaRPr>
                     </a:p>
                   </a:txBody>
-                  <a:tcPr marL="91440" marR="91440" marT="0" marB="0" anchor="ctr">
+                  <a:tcPr marT="0" marB="0" anchor="ctr">
                     <a:lnL w="12700" cap="flat" cmpd="sng" algn="ctr">
                       <a:solidFill>
                         <a:srgbClr val="D0D5D2"/>
@@ -14299,7 +13990,7 @@
                       </a:endParaRPr>
                     </a:p>
                   </a:txBody>
-                  <a:tcPr marL="91440" marR="91440" marT="0" marB="0" anchor="ctr">
+                  <a:tcPr marT="0" marB="0" anchor="ctr">
                     <a:lnL w="12700" cap="flat" cmpd="sng" algn="ctr">
                       <a:solidFill>
                         <a:srgbClr val="D0D5D2"/>
@@ -14341,6 +14032,11 @@
                     </a:solidFill>
                   </a:tcPr>
                 </a:tc>
+                <a:extLst>
+                  <a:ext uri="{0D108BD9-81ED-4DB2-BD59-A6C34878D82A}">
+                    <a16:rowId xmlns:a16="http://schemas.microsoft.com/office/drawing/2014/main" val="10000"/>
+                  </a:ext>
+                </a:extLst>
               </a:tr>
               <a:tr h="635000">
                 <a:tc>
@@ -14367,7 +14063,7 @@
                       </a:endParaRPr>
                     </a:p>
                   </a:txBody>
-                  <a:tcPr marL="91440" marR="91440" marT="0" marB="0" anchor="ctr">
+                  <a:tcPr marT="0" marB="0" anchor="ctr">
                     <a:lnL w="12700" cap="flat" cmpd="sng" algn="ctr">
                       <a:solidFill>
                         <a:srgbClr val="D0D5D2"/>
@@ -14433,7 +14129,7 @@
                       </a:endParaRPr>
                     </a:p>
                   </a:txBody>
-                  <a:tcPr marL="91440" marR="91440" marT="0" marB="0" anchor="ctr">
+                  <a:tcPr marT="0" marB="0" anchor="ctr">
                     <a:lnL w="12700" cap="flat" cmpd="sng" algn="ctr">
                       <a:solidFill>
                         <a:srgbClr val="D0D5D2"/>
@@ -14499,7 +14195,7 @@
                       </a:endParaRPr>
                     </a:p>
                   </a:txBody>
-                  <a:tcPr marL="91440" marR="91440" marT="0" marB="0" anchor="ctr">
+                  <a:tcPr marT="0" marB="0" anchor="ctr">
                     <a:lnL w="12700" cap="flat" cmpd="sng" algn="ctr">
                       <a:solidFill>
                         <a:srgbClr val="D0D5D2"/>
@@ -14541,6 +14237,11 @@
                     </a:solidFill>
                   </a:tcPr>
                 </a:tc>
+                <a:extLst>
+                  <a:ext uri="{0D108BD9-81ED-4DB2-BD59-A6C34878D82A}">
+                    <a16:rowId xmlns:a16="http://schemas.microsoft.com/office/drawing/2014/main" val="10001"/>
+                  </a:ext>
+                </a:extLst>
               </a:tr>
               <a:tr h="635000">
                 <a:tc>
@@ -14567,7 +14268,7 @@
                       </a:endParaRPr>
                     </a:p>
                   </a:txBody>
-                  <a:tcPr marL="91440" marR="91440" marT="0" marB="0" anchor="ctr">
+                  <a:tcPr marT="0" marB="0" anchor="ctr">
                     <a:lnL w="12700" cap="flat" cmpd="sng" algn="ctr">
                       <a:solidFill>
                         <a:srgbClr val="D0D5D2"/>
@@ -14633,7 +14334,7 @@
                       </a:endParaRPr>
                     </a:p>
                   </a:txBody>
-                  <a:tcPr marL="91440" marR="91440" marT="0" marB="0" anchor="ctr">
+                  <a:tcPr marT="0" marB="0" anchor="ctr">
                     <a:lnL w="12700" cap="flat" cmpd="sng" algn="ctr">
                       <a:solidFill>
                         <a:srgbClr val="D0D5D2"/>
@@ -14699,7 +14400,7 @@
                       </a:endParaRPr>
                     </a:p>
                   </a:txBody>
-                  <a:tcPr marL="91440" marR="91440" marT="0" marB="0" anchor="ctr">
+                  <a:tcPr marT="0" marB="0" anchor="ctr">
                     <a:lnL w="12700" cap="flat" cmpd="sng" algn="ctr">
                       <a:solidFill>
                         <a:srgbClr val="D0D5D2"/>
@@ -14741,6 +14442,11 @@
                     </a:solidFill>
                   </a:tcPr>
                 </a:tc>
+                <a:extLst>
+                  <a:ext uri="{0D108BD9-81ED-4DB2-BD59-A6C34878D82A}">
+                    <a16:rowId xmlns:a16="http://schemas.microsoft.com/office/drawing/2014/main" val="10002"/>
+                  </a:ext>
+                </a:extLst>
               </a:tr>
               <a:tr h="635000">
                 <a:tc>
@@ -14767,7 +14473,7 @@
                       </a:endParaRPr>
                     </a:p>
                   </a:txBody>
-                  <a:tcPr marL="91440" marR="91440" marT="0" marB="0" anchor="ctr">
+                  <a:tcPr marT="0" marB="0" anchor="ctr">
                     <a:lnL w="12700" cap="flat" cmpd="sng" algn="ctr">
                       <a:solidFill>
                         <a:srgbClr val="D0D5D2"/>
@@ -14833,7 +14539,7 @@
                       </a:endParaRPr>
                     </a:p>
                   </a:txBody>
-                  <a:tcPr marL="91440" marR="91440" marT="0" marB="0" anchor="ctr">
+                  <a:tcPr marT="0" marB="0" anchor="ctr">
                     <a:lnL w="12700" cap="flat" cmpd="sng" algn="ctr">
                       <a:solidFill>
                         <a:srgbClr val="D0D5D2"/>
@@ -14899,7 +14605,7 @@
                       </a:endParaRPr>
                     </a:p>
                   </a:txBody>
-                  <a:tcPr marL="91440" marR="91440" marT="0" marB="0" anchor="ctr">
+                  <a:tcPr marT="0" marB="0" anchor="ctr">
                     <a:lnL w="12700" cap="flat" cmpd="sng" algn="ctr">
                       <a:solidFill>
                         <a:srgbClr val="D0D5D2"/>
@@ -14941,6 +14647,11 @@
                     </a:solidFill>
                   </a:tcPr>
                 </a:tc>
+                <a:extLst>
+                  <a:ext uri="{0D108BD9-81ED-4DB2-BD59-A6C34878D82A}">
+                    <a16:rowId xmlns:a16="http://schemas.microsoft.com/office/drawing/2014/main" val="10003"/>
+                  </a:ext>
+                </a:extLst>
               </a:tr>
             </a:tbl>
           </a:graphicData>
@@ -14992,10 +14703,18 @@
   <p:clrMapOvr>
     <a:masterClrMapping/>
   </p:clrMapOvr>
-  <p:transition>
-    <p:fade/>
-    <p:spd val="med"/>
-  </p:transition>
+  <mc:AlternateContent xmlns:mc="http://schemas.openxmlformats.org/markup-compatibility/2006">
+    <mc:Choice xmlns:p159="http://schemas.microsoft.com/office/powerpoint/2015/09/main" Requires="p159">
+      <p:transition spd="slow">
+        <p159:morph option="byObject"/>
+      </p:transition>
+    </mc:Choice>
+    <mc:Fallback>
+      <p:transition spd="slow">
+        <p:fade/>
+      </p:transition>
+    </mc:Fallback>
+  </mc:AlternateContent>
 </p:sld>
 </file>
 
@@ -15007,6 +14726,7 @@
         <a:solidFill>
           <a:srgbClr val="1B5E3B"/>
         </a:solidFill>
+        <a:effectLst/>
       </p:bgPr>
     </p:bg>
     <p:spTree>
@@ -15175,10 +14895,18 @@
   <p:clrMapOvr>
     <a:masterClrMapping/>
   </p:clrMapOvr>
-  <p:transition>
-    <p:fade/>
-    <p:spd val="med"/>
-  </p:transition>
+  <mc:AlternateContent xmlns:mc="http://schemas.openxmlformats.org/markup-compatibility/2006">
+    <mc:Choice xmlns:p159="http://schemas.microsoft.com/office/powerpoint/2015/09/main" Requires="p159">
+      <p:transition spd="slow">
+        <p159:morph option="byObject"/>
+      </p:transition>
+    </mc:Choice>
+    <mc:Fallback>
+      <p:transition spd="slow">
+        <p:fade/>
+      </p:transition>
+    </mc:Fallback>
+  </mc:AlternateContent>
 </p:sld>
 </file>
 
@@ -15190,6 +14918,7 @@
         <a:solidFill>
           <a:srgbClr val="F5F5F0"/>
         </a:solidFill>
+        <a:effectLst/>
       </p:bgPr>
     </p:bg>
     <p:spTree>
@@ -15263,11 +14992,6 @@
               </a:rPr>
               <a:t>Introduction | Methodology | </a:t>
             </a:r>
-            <a:pPr algn="ctr">
-              <a:lnSpc>
-                <a:spcPct val="100000"/>
-              </a:lnSpc>
-            </a:pPr>
             <a:r>
               <a:rPr lang="en-US" sz="1200" b="1" dirty="0">
                 <a:solidFill>
@@ -15279,11 +15003,6 @@
               </a:rPr>
               <a:t>Thematic Analysis</a:t>
             </a:r>
-            <a:pPr algn="ctr">
-              <a:lnSpc>
-                <a:spcPct val="100000"/>
-              </a:lnSpc>
-            </a:pPr>
             <a:r>
               <a:rPr lang="en-US" sz="1200" dirty="0">
                 <a:solidFill>
@@ -15397,11 +15116,6 @@
               </a:rPr>
               <a:t>Three studies using </a:t>
             </a:r>
-            <a:pPr>
-              <a:lnSpc>
-                <a:spcPct val="150000"/>
-              </a:lnSpc>
-            </a:pPr>
             <a:r>
               <a:rPr lang="en-US" sz="2000" b="1" dirty="0">
                 <a:solidFill>
@@ -15413,11 +15127,6 @@
               </a:rPr>
               <a:t>handcrafted linguistic features</a:t>
             </a:r>
-            <a:pPr>
-              <a:lnSpc>
-                <a:spcPct val="150000"/>
-              </a:lnSpc>
-            </a:pPr>
             <a:r>
               <a:rPr lang="en-US" sz="2000" dirty="0">
                 <a:solidFill>
@@ -15797,14 +15506,6 @@
               </a:rPr>
               <a:t>Formulaic transitional phrases</a:t>
             </a:r>
-            <a:pPr>
-              <a:lnSpc>
-                <a:spcPct val="150000"/>
-              </a:lnSpc>
-              <a:spcBef>
-                <a:spcPts val="10"/>
-              </a:spcBef>
-            </a:pPr>
             <a:r>
               <a:rPr lang="en-US" sz="1800" dirty="0">
                 <a:solidFill>
@@ -15840,14 +15541,6 @@
               </a:rPr>
               <a:t>Low lexical entropy</a:t>
             </a:r>
-            <a:pPr>
-              <a:lnSpc>
-                <a:spcPct val="150000"/>
-              </a:lnSpc>
-              <a:spcBef>
-                <a:spcPts val="10"/>
-              </a:spcBef>
-            </a:pPr>
             <a:r>
               <a:rPr lang="en-US" sz="1800" dirty="0">
                 <a:solidFill>
@@ -15883,14 +15576,6 @@
               </a:rPr>
               <a:t>Grammatical standardization</a:t>
             </a:r>
-            <a:pPr>
-              <a:lnSpc>
-                <a:spcPct val="150000"/>
-              </a:lnSpc>
-              <a:spcBef>
-                <a:spcPts val="10"/>
-              </a:spcBef>
-            </a:pPr>
             <a:r>
               <a:rPr lang="en-US" sz="1800" dirty="0">
                 <a:solidFill>
@@ -15926,14 +15611,6 @@
               </a:rPr>
               <a:t>Punctuation regularity</a:t>
             </a:r>
-            <a:pPr>
-              <a:lnSpc>
-                <a:spcPct val="150000"/>
-              </a:lnSpc>
-              <a:spcBef>
-                <a:spcPts val="10"/>
-              </a:spcBef>
-            </a:pPr>
             <a:r>
               <a:rPr lang="en-US" sz="1800" dirty="0">
                 <a:solidFill>
@@ -15986,11 +15663,6 @@
               </a:rPr>
               <a:t>Accuracy range:</a:t>
             </a:r>
-            <a:pPr>
-              <a:lnSpc>
-                <a:spcPct val="100000"/>
-              </a:lnSpc>
-            </a:pPr>
             <a:r>
               <a:rPr lang="en-US" sz="1800" dirty="0">
                 <a:solidFill>
@@ -16002,11 +15674,6 @@
               </a:rPr>
               <a:t> 80–87% | </a:t>
             </a:r>
-            <a:pPr>
-              <a:lnSpc>
-                <a:spcPct val="100000"/>
-              </a:lnSpc>
-            </a:pPr>
             <a:r>
               <a:rPr lang="en-US" sz="1800" b="1" dirty="0">
                 <a:solidFill>
@@ -16018,11 +15685,6 @@
               </a:rPr>
               <a:t>Strength:</a:t>
             </a:r>
-            <a:pPr>
-              <a:lnSpc>
-                <a:spcPct val="100000"/>
-              </a:lnSpc>
-            </a:pPr>
             <a:r>
               <a:rPr lang="en-US" sz="1800" dirty="0">
                 <a:solidFill>
@@ -16034,11 +15696,6 @@
               </a:rPr>
               <a:t> Highly interpretable | </a:t>
             </a:r>
-            <a:pPr>
-              <a:lnSpc>
-                <a:spcPct val="100000"/>
-              </a:lnSpc>
-            </a:pPr>
             <a:r>
               <a:rPr lang="en-US" sz="1800" b="1" dirty="0">
                 <a:solidFill>
@@ -16050,11 +15707,6 @@
               </a:rPr>
               <a:t>Limitation:</a:t>
             </a:r>
-            <a:pPr>
-              <a:lnSpc>
-                <a:spcPct val="100000"/>
-              </a:lnSpc>
-            </a:pPr>
             <a:r>
               <a:rPr lang="en-US" sz="1800" dirty="0">
                 <a:solidFill>
@@ -16116,10 +15768,18 @@
   <p:clrMapOvr>
     <a:masterClrMapping/>
   </p:clrMapOvr>
-  <p:transition>
-    <p:fade/>
-    <p:spd val="med"/>
-  </p:transition>
+  <mc:AlternateContent xmlns:mc="http://schemas.openxmlformats.org/markup-compatibility/2006">
+    <mc:Choice xmlns:p159="http://schemas.microsoft.com/office/powerpoint/2015/09/main" Requires="p159">
+      <p:transition spd="slow">
+        <p159:morph option="byObject"/>
+      </p:transition>
+    </mc:Choice>
+    <mc:Fallback>
+      <p:transition spd="slow">
+        <p:fade/>
+      </p:transition>
+    </mc:Fallback>
+  </mc:AlternateContent>
 </p:sld>
 </file>
 
@@ -16131,31 +15791,326 @@
         <a:srgbClr val="000000"/>
       </a:dk1>
       <a:lt1>
-        <a:srgbClr val="ffffff"/>
+        <a:srgbClr val="FFFFFF"/>
       </a:lt1>
       <a:dk2>
         <a:srgbClr val="333333"/>
       </a:dk2>
       <a:lt2>
-        <a:srgbClr val="eeeeee"/>
+        <a:srgbClr val="EEEEEE"/>
       </a:lt2>
       <a:accent1>
-        <a:srgbClr val="8daac2"/>
+        <a:srgbClr val="8DAAC2"/>
       </a:accent1>
       <a:accent2>
-        <a:srgbClr val="ed7d31"/>
+        <a:srgbClr val="ED7D31"/>
       </a:accent2>
       <a:accent3>
-        <a:srgbClr val="a5a5a5"/>
+        <a:srgbClr val="A5A5A5"/>
       </a:accent3>
       <a:accent4>
-        <a:srgbClr val="ffc000"/>
+        <a:srgbClr val="FFC000"/>
       </a:accent4>
       <a:accent5>
-        <a:srgbClr val="4472c4"/>
+        <a:srgbClr val="4472C4"/>
       </a:accent5>
       <a:accent6>
-        <a:srgbClr val="70ad47"/>
+        <a:srgbClr val="70AD47"/>
+      </a:accent6>
+      <a:hlink>
+        <a:srgbClr val="0563C1"/>
+      </a:hlink>
+      <a:folHlink>
+        <a:srgbClr val="954F72"/>
+      </a:folHlink>
+    </a:clrScheme>
+    <a:fontScheme name="Office">
+      <a:majorFont>
+        <a:latin typeface="Calibri Light" panose="020F0302020204030204"/>
+        <a:ea typeface=""/>
+        <a:cs typeface=""/>
+        <a:font script="Jpan" typeface="游ゴシック Light"/>
+        <a:font script="Hang" typeface="맑은 고딕"/>
+        <a:font script="Hans" typeface="等线 Light"/>
+        <a:font script="Hant" typeface="新細明體"/>
+        <a:font script="Arab" typeface="Times New Roman"/>
+        <a:font script="Hebr" typeface="Times New Roman"/>
+        <a:font script="Thai" typeface="Angsana New"/>
+        <a:font script="Ethi" typeface="Nyala"/>
+        <a:font script="Beng" typeface="Vrinda"/>
+        <a:font script="Gujr" typeface="Shruti"/>
+        <a:font script="Khmr" typeface="MoolBoran"/>
+        <a:font script="Knda" typeface="Tunga"/>
+        <a:font script="Guru" typeface="Raavi"/>
+        <a:font script="Cans" typeface="Euphemia"/>
+        <a:font script="Cher" typeface="Plantagenet Cherokee"/>
+        <a:font script="Yiii" typeface="Microsoft Yi Baiti"/>
+        <a:font script="Tibt" typeface="Microsoft Himalaya"/>
+        <a:font script="Thaa" typeface="MV Boli"/>
+        <a:font script="Deva" typeface="Mangal"/>
+        <a:font script="Telu" typeface="Gautami"/>
+        <a:font script="Taml" typeface="Latha"/>
+        <a:font script="Syrc" typeface="Estrangelo Edessa"/>
+        <a:font script="Orya" typeface="Kalinga"/>
+        <a:font script="Mlym" typeface="Kartika"/>
+        <a:font script="Laoo" typeface="DokChampa"/>
+        <a:font script="Sinh" typeface="Iskoola Pota"/>
+        <a:font script="Mong" typeface="Mongolian Baiti"/>
+        <a:font script="Viet" typeface="Times New Roman"/>
+        <a:font script="Uigh" typeface="Microsoft Uighur"/>
+        <a:font script="Geor" typeface="Sylfaen"/>
+        <a:font script="Armn" typeface="Arial"/>
+        <a:font script="Bugi" typeface="Leelawadee UI"/>
+        <a:font script="Bopo" typeface="Microsoft JhengHei"/>
+        <a:font script="Java" typeface="Javanese Text"/>
+        <a:font script="Lisu" typeface="Segoe UI"/>
+        <a:font script="Mymr" typeface="Myanmar Text"/>
+        <a:font script="Nkoo" typeface="Ebrima"/>
+        <a:font script="Olck" typeface="Nirmala UI"/>
+        <a:font script="Osma" typeface="Ebrima"/>
+        <a:font script="Phag" typeface="Phagspa"/>
+        <a:font script="Syrn" typeface="Estrangelo Edessa"/>
+        <a:font script="Syrj" typeface="Estrangelo Edessa"/>
+        <a:font script="Syre" typeface="Estrangelo Edessa"/>
+        <a:font script="Sora" typeface="Nirmala UI"/>
+        <a:font script="Tale" typeface="Microsoft Tai Le"/>
+        <a:font script="Talu" typeface="Microsoft New Tai Lue"/>
+        <a:font script="Tfng" typeface="Ebrima"/>
+      </a:majorFont>
+      <a:minorFont>
+        <a:latin typeface="Calibri" panose="020F0502020204030204"/>
+        <a:ea typeface=""/>
+        <a:cs typeface=""/>
+        <a:font script="Jpan" typeface="游ゴシック"/>
+        <a:font script="Hang" typeface="맑은 고딕"/>
+        <a:font script="Hans" typeface="等线"/>
+        <a:font script="Hant" typeface="新細明體"/>
+        <a:font script="Arab" typeface="Arial"/>
+        <a:font script="Hebr" typeface="Arial"/>
+        <a:font script="Thai" typeface="Cordia New"/>
+        <a:font script="Ethi" typeface="Nyala"/>
+        <a:font script="Beng" typeface="Vrinda"/>
+        <a:font script="Gujr" typeface="Shruti"/>
+        <a:font script="Khmr" typeface="DaunPenh"/>
+        <a:font script="Knda" typeface="Tunga"/>
+        <a:font script="Guru" typeface="Raavi"/>
+        <a:font script="Cans" typeface="Euphemia"/>
+        <a:font script="Cher" typeface="Plantagenet Cherokee"/>
+        <a:font script="Yiii" typeface="Microsoft Yi Baiti"/>
+        <a:font script="Tibt" typeface="Microsoft Himalaya"/>
+        <a:font script="Thaa" typeface="MV Boli"/>
+        <a:font script="Deva" typeface="Mangal"/>
+        <a:font script="Telu" typeface="Gautami"/>
+        <a:font script="Taml" typeface="Latha"/>
+        <a:font script="Syrc" typeface="Estrangelo Edessa"/>
+        <a:font script="Orya" typeface="Kalinga"/>
+        <a:font script="Mlym" typeface="Kartika"/>
+        <a:font script="Laoo" typeface="DokChampa"/>
+        <a:font script="Sinh" typeface="Iskoola Pota"/>
+        <a:font script="Mong" typeface="Mongolian Baiti"/>
+        <a:font script="Viet" typeface="Arial"/>
+        <a:font script="Uigh" typeface="Microsoft Uighur"/>
+        <a:font script="Geor" typeface="Sylfaen"/>
+        <a:font script="Armn" typeface="Arial"/>
+        <a:font script="Bugi" typeface="Leelawadee UI"/>
+        <a:font script="Bopo" typeface="Microsoft JhengHei"/>
+        <a:font script="Java" typeface="Javanese Text"/>
+        <a:font script="Lisu" typeface="Segoe UI"/>
+        <a:font script="Mymr" typeface="Myanmar Text"/>
+        <a:font script="Nkoo" typeface="Ebrima"/>
+        <a:font script="Olck" typeface="Nirmala UI"/>
+        <a:font script="Osma" typeface="Ebrima"/>
+        <a:font script="Phag" typeface="Phagspa"/>
+        <a:font script="Syrn" typeface="Estrangelo Edessa"/>
+        <a:font script="Syrj" typeface="Estrangelo Edessa"/>
+        <a:font script="Syre" typeface="Estrangelo Edessa"/>
+        <a:font script="Sora" typeface="Nirmala UI"/>
+        <a:font script="Tale" typeface="Microsoft Tai Le"/>
+        <a:font script="Talu" typeface="Microsoft New Tai Lue"/>
+        <a:font script="Tfng" typeface="Ebrima"/>
+      </a:minorFont>
+    </a:fontScheme>
+    <a:fmtScheme name="Office">
+      <a:fillStyleLst>
+        <a:solidFill>
+          <a:schemeClr val="phClr"/>
+        </a:solidFill>
+        <a:gradFill rotWithShape="1">
+          <a:gsLst>
+            <a:gs pos="0">
+              <a:schemeClr val="phClr">
+                <a:lumMod val="110000"/>
+                <a:satMod val="105000"/>
+                <a:tint val="67000"/>
+              </a:schemeClr>
+            </a:gs>
+            <a:gs pos="50000">
+              <a:schemeClr val="phClr">
+                <a:lumMod val="105000"/>
+                <a:satMod val="103000"/>
+                <a:tint val="73000"/>
+              </a:schemeClr>
+            </a:gs>
+            <a:gs pos="100000">
+              <a:schemeClr val="phClr">
+                <a:lumMod val="105000"/>
+                <a:satMod val="109000"/>
+                <a:tint val="81000"/>
+              </a:schemeClr>
+            </a:gs>
+          </a:gsLst>
+          <a:lin ang="5400000" scaled="0"/>
+        </a:gradFill>
+        <a:gradFill rotWithShape="1">
+          <a:gsLst>
+            <a:gs pos="0">
+              <a:schemeClr val="phClr">
+                <a:satMod val="103000"/>
+                <a:lumMod val="102000"/>
+                <a:tint val="94000"/>
+              </a:schemeClr>
+            </a:gs>
+            <a:gs pos="50000">
+              <a:schemeClr val="phClr">
+                <a:satMod val="110000"/>
+                <a:lumMod val="100000"/>
+                <a:shade val="100000"/>
+              </a:schemeClr>
+            </a:gs>
+            <a:gs pos="100000">
+              <a:schemeClr val="phClr">
+                <a:lumMod val="99000"/>
+                <a:satMod val="120000"/>
+                <a:shade val="78000"/>
+              </a:schemeClr>
+            </a:gs>
+          </a:gsLst>
+          <a:lin ang="5400000" scaled="0"/>
+        </a:gradFill>
+      </a:fillStyleLst>
+      <a:lnStyleLst>
+        <a:ln w="6350" cap="flat" cmpd="sng" algn="ctr">
+          <a:solidFill>
+            <a:schemeClr val="phClr"/>
+          </a:solidFill>
+          <a:prstDash val="solid"/>
+          <a:miter lim="800000"/>
+        </a:ln>
+        <a:ln w="12700" cap="flat" cmpd="sng" algn="ctr">
+          <a:solidFill>
+            <a:schemeClr val="phClr"/>
+          </a:solidFill>
+          <a:prstDash val="solid"/>
+          <a:miter lim="800000"/>
+        </a:ln>
+        <a:ln w="19050" cap="flat" cmpd="sng" algn="ctr">
+          <a:solidFill>
+            <a:schemeClr val="phClr"/>
+          </a:solidFill>
+          <a:prstDash val="solid"/>
+          <a:miter lim="800000"/>
+        </a:ln>
+      </a:lnStyleLst>
+      <a:effectStyleLst>
+        <a:effectStyle>
+          <a:effectLst/>
+        </a:effectStyle>
+        <a:effectStyle>
+          <a:effectLst/>
+        </a:effectStyle>
+        <a:effectStyle>
+          <a:effectLst>
+            <a:outerShdw blurRad="57150" dist="19050" dir="5400000" algn="ctr" rotWithShape="0">
+              <a:srgbClr val="000000">
+                <a:alpha val="63000"/>
+              </a:srgbClr>
+            </a:outerShdw>
+          </a:effectLst>
+        </a:effectStyle>
+      </a:effectStyleLst>
+      <a:bgFillStyleLst>
+        <a:solidFill>
+          <a:schemeClr val="phClr"/>
+        </a:solidFill>
+        <a:solidFill>
+          <a:schemeClr val="phClr">
+            <a:tint val="95000"/>
+            <a:satMod val="170000"/>
+          </a:schemeClr>
+        </a:solidFill>
+        <a:gradFill rotWithShape="1">
+          <a:gsLst>
+            <a:gs pos="0">
+              <a:schemeClr val="phClr">
+                <a:tint val="93000"/>
+                <a:satMod val="150000"/>
+                <a:shade val="98000"/>
+                <a:lumMod val="102000"/>
+              </a:schemeClr>
+            </a:gs>
+            <a:gs pos="50000">
+              <a:schemeClr val="phClr">
+                <a:tint val="98000"/>
+                <a:satMod val="130000"/>
+                <a:shade val="90000"/>
+                <a:lumMod val="103000"/>
+              </a:schemeClr>
+            </a:gs>
+            <a:gs pos="100000">
+              <a:schemeClr val="phClr">
+                <a:shade val="63000"/>
+                <a:satMod val="120000"/>
+              </a:schemeClr>
+            </a:gs>
+          </a:gsLst>
+          <a:lin ang="5400000" scaled="0"/>
+        </a:gradFill>
+      </a:bgFillStyleLst>
+    </a:fmtScheme>
+  </a:themeElements>
+  <a:objectDefaults/>
+  <a:extraClrSchemeLst/>
+  <a:extLst>
+    <a:ext uri="{05A4C25C-085E-4340-85A3-A5531E510DB2}">
+      <thm15:themeFamily xmlns:thm15="http://schemas.microsoft.com/office/thememl/2012/main" name="Office Theme" id="{62F939B6-93AF-4DB8-9C6B-D6C7DFDC589F}" vid="{4A3C46E8-61CC-4603-A589-7422A47A8E4A}"/>
+    </a:ext>
+  </a:extLst>
+</a:theme>
+</file>
+
+<file path=ppt/theme/theme2.xml><?xml version="1.0" encoding="utf-8"?>
+<a:theme xmlns:a="http://schemas.openxmlformats.org/drawingml/2006/main" name="Office Theme">
+  <a:themeElements>
+    <a:clrScheme name="Office">
+      <a:dk1>
+        <a:sysClr val="windowText" lastClr="000000"/>
+      </a:dk1>
+      <a:lt1>
+        <a:sysClr val="window" lastClr="FFFFFF"/>
+      </a:lt1>
+      <a:dk2>
+        <a:srgbClr val="44546A"/>
+      </a:dk2>
+      <a:lt2>
+        <a:srgbClr val="E7E6E6"/>
+      </a:lt2>
+      <a:accent1>
+        <a:srgbClr val="4472C4"/>
+      </a:accent1>
+      <a:accent2>
+        <a:srgbClr val="ED7D31"/>
+      </a:accent2>
+      <a:accent3>
+        <a:srgbClr val="A5A5A5"/>
+      </a:accent3>
+      <a:accent4>
+        <a:srgbClr val="FFC000"/>
+      </a:accent4>
+      <a:accent5>
+        <a:srgbClr val="5B9BD5"/>
+      </a:accent5>
+      <a:accent6>
+        <a:srgbClr val="70AD47"/>
       </a:accent6>
       <a:hlink>
         <a:srgbClr val="0563C1"/>

</xml_diff>